<commit_message>
docs: redesign deployment architecture with multi-target F5 recovery flow
</commit_message>
<xml_diff>
--- a/docs/presentations/windows-cd-initial-plan.pptx
+++ b/docs/presentations/windows-cd-initial-plan.pptx
@@ -578,7 +578,7 @@
           <a:lstStyle/>
           <a:p>
             <a:r>
-              <a:t>先交代開發端直接送檔的方案為何不可行，再用同一張完整架構圖依編號說明。為守住總共 7 頁，不增加重複圖頁或動畫頁；講者沿架構圖的 ①～⑤ 說明順序。圖的組織區域、人員與工具分開呈現，技術與權限細節留在講者備註及研究文件。</a:t>
+              <a:t>先交代開發端直接送檔的方案為何不可行，再用同一張完整架構圖依編號說明。為守住總共 7 頁，不增加重複圖頁或動畫頁；第 4 頁上半部以 ①～⑧ 說明交付架構，下半部展開單台換版與復原。圖的組織區域、人員與工具分開呈現，詳細閱讀可放大獨立 PDF／draw.io。</a:t>
             </a:r>
           </a:p>
         </p:txBody>
@@ -718,52 +718,77 @@
           <a:lstStyle/>
           <a:p>
             <a:r>
-              <a:t>沿 ①～⑤ 說明同一張完整架構圖，不增加重複頁。ADO 全名 Azure DevOps Server，POC 使用 Express；基線 Server 2022／REST 7.0，實際版本與修補層級待安裝確認。本圖是文件支持的目標架構，不是已實機測通的現況。</a:t>
-            </a:r>
-          </a:p>
-          <a:p>
-            <a:r>
-              <a:t>① 開發人員 push 到 GitLab CE；GitLab 編排 CI，GitLab Runner 執行建置／測試並將 artifact 上傳回 GitLab。Runner 沒有 Production 存取權或 ADO 部署憑證。</a:t>
-            </a:r>
-          </a:p>
-          <a:p>
-            <a:r>
-              <a:t>② GitLab pipeline 狀態成功後以 Pipeline webhook 主動通知管理側的受保護接收器；不是 GitLab Runner 直接觸發正式部署。接收器驗證認證、限制來源、耐久入列，再以 GitLab API 複核專案、成功狀態、來源分支、SHA 與必要品質 job，最後透過 Queue Build REST API 排入固定 importer。接收器是需實作的服務，不是另一個 GitLab Runner，也不是 ADO 原生 GitLab artifact connector；可評估與管理 Agent 共用非正式主機，但服務身分、憑證與目錄必須隔離。</a:t>
-            </a:r>
-          </a:p>
-          <a:p>
-            <a:r>
-              <a:t>③ ADO 需要管理區的 self-hosted Build Agent 執行 importer。圖中 GitLab→管理 Agent 是 API 下載的資料流，實際連線由管理 Agent 發起；ADO→管理 Agent 是派工語意，Agent 主動連 Server 取工作。Importer 重驗固定來源政策，按 project/pipeline/job ID 下載確切 artifact，檢查 ZIP 與內容、計算 hash、保存來源 manifest，再以 PublishBuildArtifacts@1 發布 Server Build Artifacts。不能用 Services-only Pipeline Artifacts，不能在部署時抓 latest。GitLab 唯讀憑證只留管理區。Management Agent 與 Production Deployment Group Agent 不共用主機、帳號或 pool；管理 Agent 不可寫入 Production。圖中 ADO 是控制面與受控版本儲存的概念集合，不代表所有元件必須同機。</a:t>
-            </a:r>
-          </a:p>
-          <a:p>
-            <a:r>
-              <a:t>④ 以三組固定 importer／Classic Release 綁定來源環境，下一頁展開。SIT／UAT 可在匯入成功後自動建立 release／部署。Production 關閉 artifact 自動 release trigger，由授權人員選確切 importer build 建立 Release；stage 設 Manual only 與具名 pre-deployment approvers。允許同一授權人員發起與放行，不強制雙人審批。放行綁定應用、目標與確切內容，改版或改目標須重新放行。</a:t>
-            </a:r>
-          </a:p>
-          <a:p>
-            <a:r>
-              <a:t>⑤ 圖中 ADO→部署 Agent 是已授權工作的交接，不是 Server 主動登入 Windows。每台 Windows Target 安裝專用 Deployment Group Agent，主動連 ADO 取工作，放行後才下載指定 build 產物並以受保護的部署腳本切換本機應用。此處畫 Production，SIT／UAT 使用各自隔離的 target Agents。沒有另藏一個需要登入正式主機的管理 Runner；本方案使用目標 Agent 本機執行。必須測試未放行時正式主機連 Agent 工作目錄都沒有候選檔案寫入。</a:t>
-            </a:r>
-          </a:p>
-          <a:p>
-            <a:r>
-              <a:t>安全邊界：接收器的 PAT／帳號只允許排入固定 importer，不具有 Release／Production 權限；PAT scope 不等於 definition ACL，須測試群組繼承、來源分支／參數覆寫、build service 身分與 OS 帳號的有效權限。部署定義、來源映射與特權腳本由授權部門管理，不能執行 artifact 附帶的特權腳本。記錄人員、版本、目標與結果。</a:t>
-            </a:r>
-          </a:p>
-          <a:p>
-            <a:r>
-              <a:t>可靠性：接收器耐久 inbox、去重、重送與 importer 候選唯一鍵，處理 Queue 回應遺失、重複事件及晚到舊版本；不讓重複匯入再觸發部署。必要品質 jobs 必須成功，不能只信任 allow_failure 後仍 success 的 pipeline。正常路徑為事件驅動；漏事件由受控補送走同一驗證流程，並監控 webhook 停用與產物保留期限。</a:t>
-            </a:r>
-          </a:p>
-          <a:p>
-            <a:r>
-              <a:t>研究取捨：CI 最後一個 job 直呼 Queue API 有官方功能基礎，但持有匯入排程權限且整條 pipeline 此時可能仍 running，需要事件後有限狀態重查；所以首選成功 webhook。Server 2020.1 起有 incoming webhook 功能，不能說是 Services-only，但其 HMAC 與 GitLab 的驗證格式不可假設相容。採接收器＋Queue API，不依賴未驗證的原生互通性。</a:t>
-            </a:r>
-          </a:p>
-          <a:p>
-            <a:r>
-              <a:t>完整查證與 POC 負向測試：docs/research/gitlab-ado-event-trigger.md。</a:t>
+              <a:t>本頁 v0.7 改為完整架構圖圖片，PPTX 中是高解析圖片，可編輯節點、容器與連線的原檔為 docs/presentations/diagrams/windows-deployment-map.drawio；獨立 PDF 可放大閱讀。圖內主架構與單台換版流程是兩個明確分隔的視圖，不是假裝一張純網路拓樸。圖面研究見 docs/research/end-to-end-architecture-diagram-design.md。</a:t>
+            </a:r>
+          </a:p>
+          <a:p>
+            <a:r>
+              <a:t>使用者確認：替換第 4 頁；「下 F5／上 F5」分別表示將目標服務退出／恢復負載平衡流量。具體 pool/member、Disabled 或 Forced Offline、連線等待／逾時、F5 操作位置與身分仍待網路及主機團隊確認。不能從圖推論每台 Agent 持有 F5 管理權；實作時需接上受保護、可稽核的維護操作。F5 流量線指向應用，不是 Agent；一台主機可能有多個 pool members，須確認完整範圍。</a:t>
+            </a:r>
+          </a:p>
+          <a:p>
+            <a:r>
+              <a:t>上半部是交付架構：開發人員 push GitLab CE；GitLab 編排 CI，GitLab Runner 建置／測試並上傳 artifact。GitLab pipeline 成功事件通知受保護接收器，接收器驗證、耐久入列、API 複核後，以 Queue Build REST API 排入固定 importer。接收器與驗證／去重邏輯需實作，不是原生 GitLab artifact connector，也不需要新增 GitLab Runner。</a:t>
+            </a:r>
+          </a:p>
+          <a:p>
+            <a:r>
+              <a:t>ADO 管理區的 self-hosted Build Agent 重驗專案、pipeline、ref、SHA 與必要品質 jobs，按確切 project/pipeline/job ID 下載 GitLab 產物，驗 ZIP／hash 並保存 manifest，以 PublishBuildArtifacts@1 發布 Server Build Artifacts。不能抓 latest 或使用 Services-only Pipeline Artifacts。GitLab 唯讀憑證只留管理區；管理 Agent、接收器和 CI 都無 Production 存取權。</a:t>
+            </a:r>
+          </a:p>
+          <a:p>
+            <a:r>
+              <a:t>ADO 全名 Azure DevOps Server；Express 為 POC 起點，Server 2022／REST 7.0 作文件基線。ADO 控制面、版本庫、管理 Agent 是邏輯元件，不等於必須各有一台 VM。這是文件支持的目標設計，不是現況或實機測通的證明。</a:t>
+            </a:r>
+          </a:p>
+          <a:p>
+            <a:r>
+              <a:t>Production 關閉 artifact 自動 release trigger，授權人員選確切 importer build、應用與目標建立 Classic Release，stage 設 Manual only 與具名 pre-deployment approval；允許同一人發起與放行。任何版本／目標變更須重新放行。SIT/UAT 的三分支分流留下一頁說明。</a:t>
+            </a:r>
+          </a:p>
+          <a:p>
+            <a:r>
+              <a:t>放行後，各 Windows Target 上的專用 Deployment Group Agent 才取指定工作與產物，在本機執行受保護的部署腳本。Agent 主動連 ADO 取工作；派工箭頭不代表 Server 主動登入 Windows。放行前不得預拷，包含 Production Agent 工作目錄。管理 Agent 與目標 Agent 必須隔離帳號、pool／Deployment Group、主機與憑證，不能執行開發者提供的特權部署腳本。</a:t>
+            </a:r>
+          </a:p>
+          <a:p>
+            <a:r>
+              <a:t>Production 圖示 01、02、…、N，可涵蓋數十台主機；不代表所有主機同時換版，也不是 Agent 互相傳檔。暫建議逐台或受控分批，健康後繼續，任一失敗停止後續目標；批次大小、最低容量、先前成功目標是否回復仍待確認。不承諾零停機或跨主機原子交易。</a:t>
+            </a:r>
+          </a:p>
+          <a:p>
+            <a:r>
+              <a:t>下半部對每個核准目標重複：放行後下載／驗證、部署鎖與前置檢查 → 下 F5 並確認流量隔離條件 → 停止服務 → 備份目前版本 → 執行換版 → 重啟服務 → 檢查狀態。正常才上 F5，確認恢復成功後記錄新版本完成。</a:t>
+            </a:r>
+          </a:p>
+          <a:p>
+            <a:r>
+              <a:t>換版、啟動或健康檢查失敗時，保持隔離，依受控腳本停止失敗版本、回復有效備份、重啟，再做復原健康檢查；正常才上 F5 並記錄「換版失敗、復原成功」，不能記為新版本部署成功。復原不健康或無可用備份時，保持隔離、停止後續換版、告警並交人員處理。</a:t>
+            </a:r>
+          </a:p>
+          <a:p>
+            <a:r>
+              <a:t>下 F5／隔離確認失敗時不能繼續停止服務；停止或備份失敗時不能覆寫版本，由受控復原／人工程序決定後續。上 F5 操作或確認失敗不能算完成。檔案備份不等於資料庫回復，資料相容與復原另行設計。服務停止／重啟需依 IIS／Windows Service 細化。備份與復原腳本必須演練，ADO／Agent 不自動提供完整應用復原。</a:t>
+            </a:r>
+          </a:p>
+          <a:p>
+            <a:r>
+              <a:t>安全與可靠性驗收：測試 PAT／definition ACL／群組繼承、queue 參數與來源覆寫、build service／OS 身分、特權腳本保護；測試事件偽造、重送、晚到舊版本、Queue 回應遺失、產物到期、零預拷、拒絕或復原失敗時不恢復流量。版本、人員、目標、hash 與結果可追溯。</a:t>
+            </a:r>
+          </a:p>
+          <a:p>
+            <a:r>
+              <a:t>完整串接依據：docs/research/gitlab-ado-event-trigger.md。</a:t>
+            </a:r>
+          </a:p>
+          <a:p>
+            <a:r>
+              <a:t>https://c4model.com/diagrams/notation</a:t>
+            </a:r>
+          </a:p>
+          <a:p>
+            <a:r>
+              <a:t>https://learn.microsoft.com/en-us/azure/well-architected/architect-role/design-diagrams</a:t>
             </a:r>
           </a:p>
           <a:p>
@@ -778,12 +803,12 @@
           </a:p>
           <a:p>
             <a:r>
-              <a:t>https://learn.microsoft.com/en-us/azure/devops/pipelines/tasks/reference/publish-build-artifacts-v1?view=azure-pipelines</a:t>
-            </a:r>
-          </a:p>
-          <a:p>
-            <a:r>
               <a:t>https://learn.microsoft.com/en-us/azure/devops/pipelines/release/deployment-groups/?view=azure-devops-2022</a:t>
+            </a:r>
+          </a:p>
+          <a:p>
+            <a:r>
+              <a:t>https://techdocs.f5.com/kb/en-us/products/big-ip_ltm/manuals/product/big-ip-local-traffic-management-basics-14-0-0/05.html</a:t>
             </a:r>
           </a:p>
         </p:txBody>
@@ -938,7 +963,7 @@
           <a:lstStyle/>
           <a:p>
             <a:r>
-              <a:t>保留並調整舊版第 9 頁。放行前產物只在管理區保存，不能預拷到 Production（包含 Agent 工作目錄）；放行後部署 Agent 取固定 importer build 的 artifact，重新核對內容 hash，保存目前版本與復原資料，再依 IIS／Windows Service 的需求停止或切換、套用環境設定、啟動及健康驗證。不承諾零停機或跨主機原子交易。</a:t>
+              <a:t>本頁是換版與復原概覽；完整的下 F5、停服務、備份、換版、重啟、健康檢查、恢復流量及復原失敗分支已展開於第 4 頁。復原健康才回池，復原成功仍屬換版失敗，不記新版本部署完成。保留並調整舊版第 9 頁。放行前產物只在管理區保存，不能預拷到 Production（包含 Agent 工作目錄）；放行後部署 Agent 取固定 importer build 的 artifact，重新核對內容 hash，保存目前版本與復原資料，再依 IIS／Windows Service 的需求停止或切換、套用環境設定、啟動及健康驗證。不承諾零停機或跨主機原子交易。</a:t>
             </a:r>
           </a:p>
           <a:p>
@@ -4529,7 +4554,7 @@
               </a:defRPr>
             </a:pPr>
             <a:r>
-              <a:t>v0.6  |  初步計劃 · 正式上線另需批准</a:t>
+              <a:t>v0.7  |  初步計劃 · 正式上線另需批准</a:t>
             </a:r>
           </a:p>
         </p:txBody>
@@ -5910,7 +5935,7 @@
               </a:defRPr>
             </a:pPr>
             <a:r>
-              <a:t>v0.6  |  初步計劃 · 正式上線另需批准</a:t>
+              <a:t>v0.7  |  初步計劃 · 正式上線另需批准</a:t>
             </a:r>
           </a:p>
         </p:txBody>
@@ -7098,7 +7123,7 @@
               </a:defRPr>
             </a:pPr>
             <a:r>
-              <a:t>v0.6  |  初步計劃 · 正式上線另需批准</a:t>
+              <a:t>v0.7  |  初步計劃 · 正式上線另需批准</a:t>
             </a:r>
           </a:p>
         </p:txBody>
@@ -7168,137 +7193,6 @@
       <p:grpSpPr/>
       <p:sp>
         <p:nvSpPr>
-          <p:cNvPr id="3" name="Rectangle 2"/>
-          <p:cNvSpPr/>
-          <p:nvPr/>
-        </p:nvSpPr>
-        <p:spPr>
-          <a:xfrm>
-            <a:off x="0" y="0"/>
-            <a:ext cx="12192000" cy="6858000"/>
-          </a:xfrm>
-          <a:prstGeom prst="rect">
-            <a:avLst/>
-          </a:prstGeom>
-          <a:solidFill>
-            <a:srgbClr val="F3F6FA"/>
-          </a:solidFill>
-          <a:ln>
-            <a:noFill/>
-          </a:ln>
-        </p:spPr>
-        <p:style>
-          <a:lnRef idx="1">
-            <a:schemeClr val="accent1"/>
-          </a:lnRef>
-          <a:fillRef idx="3">
-            <a:schemeClr val="accent1"/>
-          </a:fillRef>
-          <a:effectRef idx="2">
-            <a:schemeClr val="accent1"/>
-          </a:effectRef>
-          <a:fontRef idx="minor">
-            <a:schemeClr val="lt1"/>
-          </a:fontRef>
-        </p:style>
-        <p:txBody>
-          <a:bodyPr rtlCol="0" anchor="ctr"/>
-          <a:lstStyle/>
-          <a:p>
-            <a:pPr algn="ctr"/>
-          </a:p>
-        </p:txBody>
-      </p:sp>
-      <p:sp>
-        <p:nvSpPr>
-          <p:cNvPr id="4" name="Rectangle 3"/>
-          <p:cNvSpPr/>
-          <p:nvPr/>
-        </p:nvSpPr>
-        <p:spPr>
-          <a:xfrm>
-            <a:off x="0" y="0"/>
-            <a:ext cx="114300" cy="6858000"/>
-          </a:xfrm>
-          <a:prstGeom prst="rect">
-            <a:avLst/>
-          </a:prstGeom>
-          <a:solidFill>
-            <a:srgbClr val="087F8C"/>
-          </a:solidFill>
-          <a:ln>
-            <a:noFill/>
-          </a:ln>
-        </p:spPr>
-        <p:style>
-          <a:lnRef idx="1">
-            <a:schemeClr val="accent1"/>
-          </a:lnRef>
-          <a:fillRef idx="3">
-            <a:schemeClr val="accent1"/>
-          </a:fillRef>
-          <a:effectRef idx="2">
-            <a:schemeClr val="accent1"/>
-          </a:effectRef>
-          <a:fontRef idx="minor">
-            <a:schemeClr val="lt1"/>
-          </a:fontRef>
-        </p:style>
-        <p:txBody>
-          <a:bodyPr rtlCol="0" anchor="ctr"/>
-          <a:lstStyle/>
-          <a:p>
-            <a:pPr algn="ctr"/>
-          </a:p>
-        </p:txBody>
-      </p:sp>
-      <p:sp>
-        <p:nvSpPr>
-          <p:cNvPr id="5" name="TextBox 4"/>
-          <p:cNvSpPr txBox="1"/>
-          <p:nvPr/>
-        </p:nvSpPr>
-        <p:spPr>
-          <a:xfrm>
-            <a:off x="508000" y="317500"/>
-            <a:ext cx="11176000" cy="231140"/>
-          </a:xfrm>
-          <a:prstGeom prst="rect">
-            <a:avLst/>
-          </a:prstGeom>
-          <a:noFill/>
-        </p:spPr>
-        <p:txBody>
-          <a:bodyPr wrap="none" lIns="0" rIns="0" tIns="0" bIns="0" anchor="t">
-            <a:spAutoFit/>
-          </a:bodyPr>
-          <a:lstStyle/>
-          <a:p>
-            <a:pPr algn="l">
-              <a:lnSpc>
-                <a:spcPts val="1620"/>
-              </a:lnSpc>
-              <a:spcBef>
-                <a:spcPts val="0"/>
-              </a:spcBef>
-              <a:spcAft>
-                <a:spcPts val="0"/>
-              </a:spcAft>
-              <a:defRPr sz="1200" b="1">
-                <a:solidFill>
-                  <a:srgbClr val="087F8C"/>
-                </a:solidFill>
-                <a:latin typeface="Microsoft JhengHei"/>
-              </a:defRPr>
-            </a:pPr>
-            <a:r>
-              <a:t>WINDOWS DEPLOYMENT  /  跨部門討論提案</a:t>
-            </a:r>
-          </a:p>
-        </p:txBody>
-      </p:sp>
-      <p:sp>
-        <p:nvSpPr>
           <p:cNvPr id="2" name="Title 1"/>
           <p:cNvSpPr>
             <a:spLocks noGrp="1"/>
@@ -7307,107 +7201,36 @@
             <p:ph type="title"/>
           </p:nvPr>
         </p:nvSpPr>
-        <p:spPr>
-          <a:xfrm>
-            <a:off x="508000" y="787400"/>
-            <a:ext cx="11176000" cy="574040"/>
-          </a:xfrm>
-        </p:spPr>
-        <p:txBody>
-          <a:bodyPr lIns="0" rIns="0" tIns="0" bIns="0" wrap="none" anchor="t"/>
-          <a:lstStyle/>
-          <a:p>
-            <a:pPr algn="l">
-              <a:lnSpc>
-                <a:spcPts val="4320"/>
-              </a:lnSpc>
-              <a:spcBef>
-                <a:spcPts val="0"/>
-              </a:spcBef>
-              <a:spcAft>
-                <a:spcPts val="0"/>
-              </a:spcAft>
-              <a:defRPr sz="3200" b="1">
-                <a:solidFill>
-                  <a:srgbClr val="142C42"/>
-                </a:solidFill>
-                <a:latin typeface="Microsoft JhengHei"/>
-              </a:defRPr>
-            </a:pPr>
-            <a:r>
-              <a:t>建置完成主動通知，ADO 接手匯入與授權部署</a:t>
-            </a:r>
-          </a:p>
-        </p:txBody>
-      </p:sp>
-      <p:sp>
-        <p:nvSpPr>
-          <p:cNvPr id="6" name="TextBox 5"/>
-          <p:cNvSpPr txBox="1"/>
-          <p:nvPr/>
-        </p:nvSpPr>
-        <p:spPr>
-          <a:xfrm>
-            <a:off x="508000" y="1435100"/>
-            <a:ext cx="11176000" cy="385445"/>
+        <p:spPr/>
+        <p:txBody>
+          <a:bodyPr/>
+          <a:lstStyle/>
+          <a:p>
+            <a:r>
+              <a:t>Windows 正式部署：從提交程式碼到多機換版與復原</a:t>
+            </a:r>
+          </a:p>
+        </p:txBody>
+      </p:sp>
+      <p:sp>
+        <p:nvSpPr>
+          <p:cNvPr id="3" name="Rectangle 2"/>
+          <p:cNvSpPr/>
+          <p:nvPr/>
+        </p:nvSpPr>
+        <p:spPr>
+          <a:xfrm>
+            <a:off x="0" y="0"/>
+            <a:ext cx="12192000" cy="6858000"/>
           </a:xfrm>
           <a:prstGeom prst="rect">
             <a:avLst/>
-          </a:prstGeom>
-          <a:noFill/>
-        </p:spPr>
-        <p:txBody>
-          <a:bodyPr wrap="none" lIns="0" rIns="0" tIns="0" bIns="0" anchor="t">
-            <a:spAutoFit/>
-          </a:bodyPr>
-          <a:lstStyle/>
-          <a:p>
-            <a:pPr algn="l">
-              <a:lnSpc>
-                <a:spcPts val="2835"/>
-              </a:lnSpc>
-              <a:spcBef>
-                <a:spcPts val="0"/>
-              </a:spcBef>
-              <a:spcAft>
-                <a:spcPts val="0"/>
-              </a:spcAft>
-              <a:defRPr sz="2100" b="0">
-                <a:solidFill>
-                  <a:srgbClr val="52677B"/>
-                </a:solidFill>
-                <a:latin typeface="Microsoft JhengHei"/>
-              </a:defRPr>
-            </a:pPr>
-            <a:r>
-              <a:t>分區＝責任邊界；橘色＝人員；箭頭＝工作／產物交接</a:t>
-            </a:r>
-          </a:p>
-        </p:txBody>
-      </p:sp>
-      <p:sp>
-        <p:nvSpPr>
-          <p:cNvPr id="7" name="Rounded Rectangle 6"/>
-          <p:cNvSpPr/>
-          <p:nvPr/>
-        </p:nvSpPr>
-        <p:spPr>
-          <a:xfrm>
-            <a:off x="508000" y="2095500"/>
-            <a:ext cx="3048000" cy="3556000"/>
-          </a:xfrm>
-          <a:prstGeom prst="roundRect">
-            <a:avLst>
-              <a:gd name="adj" fmla="val 8000"/>
-            </a:avLst>
           </a:prstGeom>
           <a:solidFill>
             <a:srgbClr val="FFFFFF"/>
           </a:solidFill>
-          <a:ln w="10160">
-            <a:solidFill>
-              <a:srgbClr val="DCE5EE"/>
-            </a:solidFill>
+          <a:ln>
+            <a:noFill/>
           </a:ln>
         </p:spPr>
         <p:style>
@@ -7432,2674 +7255,30 @@
           </a:p>
         </p:txBody>
       </p:sp>
-      <p:sp>
-        <p:nvSpPr>
-          <p:cNvPr id="8" name="Rectangle 7"/>
-          <p:cNvSpPr/>
-          <p:nvPr/>
-        </p:nvSpPr>
-        <p:spPr>
-          <a:xfrm>
-            <a:off x="508000" y="2095500"/>
-            <a:ext cx="3048000" cy="431800"/>
+      <p:pic>
+        <p:nvPicPr>
+          <p:cNvPr id="4" name="Picture 3" descr="Windows 正式部署端到端架構：開發人員提交 GitLab，Runner 建置測試，成功事件通知受控接收器，ADO 管理 Agent 匯入固定產物，授權部署人員放行，由多台 Windows Target 的 Agent 換版；下方展開退出 F5、停服務、備份、換版、重啟、健康檢查與退版分支。"/>
+          <p:cNvPicPr>
+            <a:picLocks noChangeAspect="1"/>
+          </p:cNvPicPr>
+          <p:nvPr/>
+        </p:nvPicPr>
+        <p:blipFill>
+          <a:blip r:embed="rId2"/>
+          <a:stretch>
+            <a:fillRect/>
+          </a:stretch>
+        </p:blipFill>
+        <p:spPr>
+          <a:xfrm>
+            <a:off x="0" y="0"/>
+            <a:ext cx="12192000" cy="6858000"/>
           </a:xfrm>
           <a:prstGeom prst="rect">
             <a:avLst/>
           </a:prstGeom>
-          <a:solidFill>
-            <a:srgbClr val="E4EBF3"/>
-          </a:solidFill>
-          <a:ln>
-            <a:noFill/>
-          </a:ln>
-        </p:spPr>
-        <p:style>
-          <a:lnRef idx="1">
-            <a:schemeClr val="accent1"/>
-          </a:lnRef>
-          <a:fillRef idx="3">
-            <a:schemeClr val="accent1"/>
-          </a:fillRef>
-          <a:effectRef idx="2">
-            <a:schemeClr val="accent1"/>
-          </a:effectRef>
-          <a:fontRef idx="minor">
-            <a:schemeClr val="lt1"/>
-          </a:fontRef>
-        </p:style>
-        <p:txBody>
-          <a:bodyPr rtlCol="0" anchor="ctr"/>
-          <a:lstStyle/>
-          <a:p>
-            <a:pPr algn="ctr"/>
-          </a:p>
-        </p:txBody>
-      </p:sp>
-      <p:sp>
-        <p:nvSpPr>
-          <p:cNvPr id="9" name="TextBox 8"/>
-          <p:cNvSpPr txBox="1"/>
-          <p:nvPr/>
-        </p:nvSpPr>
-        <p:spPr>
-          <a:xfrm>
-            <a:off x="660400" y="2146300"/>
-            <a:ext cx="2743200" cy="334010"/>
-          </a:xfrm>
-          <a:prstGeom prst="rect">
-            <a:avLst/>
-          </a:prstGeom>
-          <a:noFill/>
-        </p:spPr>
-        <p:txBody>
-          <a:bodyPr wrap="none" lIns="0" rIns="0" tIns="0" bIns="0" anchor="t">
-            <a:spAutoFit/>
-          </a:bodyPr>
-          <a:lstStyle/>
-          <a:p>
-            <a:pPr algn="l">
-              <a:lnSpc>
-                <a:spcPts val="2430"/>
-              </a:lnSpc>
-              <a:spcBef>
-                <a:spcPts val="0"/>
-              </a:spcBef>
-              <a:spcAft>
-                <a:spcPts val="0"/>
-              </a:spcAft>
-              <a:defRPr sz="1800" b="1">
-                <a:solidFill>
-                  <a:srgbClr val="142C42"/>
-                </a:solidFill>
-                <a:latin typeface="Microsoft JhengHei"/>
-              </a:defRPr>
-            </a:pPr>
-            <a:r>
-              <a:t>開發區：不持正式權限</a:t>
-            </a:r>
-          </a:p>
-        </p:txBody>
-      </p:sp>
-      <p:sp>
-        <p:nvSpPr>
-          <p:cNvPr id="10" name="Rounded Rectangle 9"/>
-          <p:cNvSpPr/>
-          <p:nvPr/>
-        </p:nvSpPr>
-        <p:spPr>
-          <a:xfrm>
-            <a:off x="3937000" y="2095500"/>
-            <a:ext cx="4953000" cy="3556000"/>
-          </a:xfrm>
-          <a:prstGeom prst="roundRect">
-            <a:avLst>
-              <a:gd name="adj" fmla="val 8000"/>
-            </a:avLst>
-          </a:prstGeom>
-          <a:solidFill>
-            <a:srgbClr val="FFFFFF"/>
-          </a:solidFill>
-          <a:ln w="10160">
-            <a:solidFill>
-              <a:srgbClr val="DCE5EE"/>
-            </a:solidFill>
-          </a:ln>
-        </p:spPr>
-        <p:style>
-          <a:lnRef idx="1">
-            <a:schemeClr val="accent1"/>
-          </a:lnRef>
-          <a:fillRef idx="3">
-            <a:schemeClr val="accent1"/>
-          </a:fillRef>
-          <a:effectRef idx="2">
-            <a:schemeClr val="accent1"/>
-          </a:effectRef>
-          <a:fontRef idx="minor">
-            <a:schemeClr val="lt1"/>
-          </a:fontRef>
-        </p:style>
-        <p:txBody>
-          <a:bodyPr rtlCol="0" anchor="ctr"/>
-          <a:lstStyle/>
-          <a:p>
-            <a:pPr algn="ctr"/>
-          </a:p>
-        </p:txBody>
-      </p:sp>
-      <p:sp>
-        <p:nvSpPr>
-          <p:cNvPr id="11" name="Rectangle 10"/>
-          <p:cNvSpPr/>
-          <p:nvPr/>
-        </p:nvSpPr>
-        <p:spPr>
-          <a:xfrm>
-            <a:off x="3937000" y="2095500"/>
-            <a:ext cx="4953000" cy="431800"/>
-          </a:xfrm>
-          <a:prstGeom prst="rect">
-            <a:avLst/>
-          </a:prstGeom>
-          <a:solidFill>
-            <a:srgbClr val="E4EBF3"/>
-          </a:solidFill>
-          <a:ln>
-            <a:noFill/>
-          </a:ln>
-        </p:spPr>
-        <p:style>
-          <a:lnRef idx="1">
-            <a:schemeClr val="accent1"/>
-          </a:lnRef>
-          <a:fillRef idx="3">
-            <a:schemeClr val="accent1"/>
-          </a:fillRef>
-          <a:effectRef idx="2">
-            <a:schemeClr val="accent1"/>
-          </a:effectRef>
-          <a:fontRef idx="minor">
-            <a:schemeClr val="lt1"/>
-          </a:fontRef>
-        </p:style>
-        <p:txBody>
-          <a:bodyPr rtlCol="0" anchor="ctr"/>
-          <a:lstStyle/>
-          <a:p>
-            <a:pPr algn="ctr"/>
-          </a:p>
-        </p:txBody>
-      </p:sp>
-      <p:sp>
-        <p:nvSpPr>
-          <p:cNvPr id="12" name="TextBox 11"/>
-          <p:cNvSpPr txBox="1"/>
-          <p:nvPr/>
-        </p:nvSpPr>
-        <p:spPr>
-          <a:xfrm>
-            <a:off x="4089400" y="2146300"/>
-            <a:ext cx="4648200" cy="334010"/>
-          </a:xfrm>
-          <a:prstGeom prst="rect">
-            <a:avLst/>
-          </a:prstGeom>
-          <a:noFill/>
-        </p:spPr>
-        <p:txBody>
-          <a:bodyPr wrap="none" lIns="0" rIns="0" tIns="0" bIns="0" anchor="t">
-            <a:spAutoFit/>
-          </a:bodyPr>
-          <a:lstStyle/>
-          <a:p>
-            <a:pPr algn="l">
-              <a:lnSpc>
-                <a:spcPts val="2430"/>
-              </a:lnSpc>
-              <a:spcBef>
-                <a:spcPts val="0"/>
-              </a:spcBef>
-              <a:spcAft>
-                <a:spcPts val="0"/>
-              </a:spcAft>
-              <a:defRPr sz="1800" b="1">
-                <a:solidFill>
-                  <a:srgbClr val="142C42"/>
-                </a:solidFill>
-                <a:latin typeface="Microsoft JhengHei"/>
-              </a:defRPr>
-            </a:pPr>
-            <a:r>
-              <a:t>授權部門管理區（非正式主機）</a:t>
-            </a:r>
-          </a:p>
-        </p:txBody>
-      </p:sp>
-      <p:sp>
-        <p:nvSpPr>
-          <p:cNvPr id="13" name="Rounded Rectangle 12"/>
-          <p:cNvSpPr/>
-          <p:nvPr/>
-        </p:nvSpPr>
-        <p:spPr>
-          <a:xfrm>
-            <a:off x="9271000" y="2095500"/>
-            <a:ext cx="2413000" cy="3556000"/>
-          </a:xfrm>
-          <a:prstGeom prst="roundRect">
-            <a:avLst>
-              <a:gd name="adj" fmla="val 8000"/>
-            </a:avLst>
-          </a:prstGeom>
-          <a:solidFill>
-            <a:srgbClr val="FFFFFF"/>
-          </a:solidFill>
-          <a:ln w="10160">
-            <a:solidFill>
-              <a:srgbClr val="DCE5EE"/>
-            </a:solidFill>
-          </a:ln>
-        </p:spPr>
-        <p:style>
-          <a:lnRef idx="1">
-            <a:schemeClr val="accent1"/>
-          </a:lnRef>
-          <a:fillRef idx="3">
-            <a:schemeClr val="accent1"/>
-          </a:fillRef>
-          <a:effectRef idx="2">
-            <a:schemeClr val="accent1"/>
-          </a:effectRef>
-          <a:fontRef idx="minor">
-            <a:schemeClr val="lt1"/>
-          </a:fontRef>
-        </p:style>
-        <p:txBody>
-          <a:bodyPr rtlCol="0" anchor="ctr"/>
-          <a:lstStyle/>
-          <a:p>
-            <a:pPr algn="ctr"/>
-          </a:p>
-        </p:txBody>
-      </p:sp>
-      <p:sp>
-        <p:nvSpPr>
-          <p:cNvPr id="14" name="Rectangle 13"/>
-          <p:cNvSpPr/>
-          <p:nvPr/>
-        </p:nvSpPr>
-        <p:spPr>
-          <a:xfrm>
-            <a:off x="9271000" y="2095500"/>
-            <a:ext cx="2413000" cy="431800"/>
-          </a:xfrm>
-          <a:prstGeom prst="rect">
-            <a:avLst/>
-          </a:prstGeom>
-          <a:solidFill>
-            <a:srgbClr val="E4EBF3"/>
-          </a:solidFill>
-          <a:ln>
-            <a:noFill/>
-          </a:ln>
-        </p:spPr>
-        <p:style>
-          <a:lnRef idx="1">
-            <a:schemeClr val="accent1"/>
-          </a:lnRef>
-          <a:fillRef idx="3">
-            <a:schemeClr val="accent1"/>
-          </a:fillRef>
-          <a:effectRef idx="2">
-            <a:schemeClr val="accent1"/>
-          </a:effectRef>
-          <a:fontRef idx="minor">
-            <a:schemeClr val="lt1"/>
-          </a:fontRef>
-        </p:style>
-        <p:txBody>
-          <a:bodyPr rtlCol="0" anchor="ctr"/>
-          <a:lstStyle/>
-          <a:p>
-            <a:pPr algn="ctr"/>
-          </a:p>
-        </p:txBody>
-      </p:sp>
-      <p:sp>
-        <p:nvSpPr>
-          <p:cNvPr id="15" name="TextBox 14"/>
-          <p:cNvSpPr txBox="1"/>
-          <p:nvPr/>
-        </p:nvSpPr>
-        <p:spPr>
-          <a:xfrm>
-            <a:off x="9423400" y="2146300"/>
-            <a:ext cx="2108200" cy="334010"/>
-          </a:xfrm>
-          <a:prstGeom prst="rect">
-            <a:avLst/>
-          </a:prstGeom>
-          <a:noFill/>
-        </p:spPr>
-        <p:txBody>
-          <a:bodyPr wrap="none" lIns="0" rIns="0" tIns="0" bIns="0" anchor="t">
-            <a:spAutoFit/>
-          </a:bodyPr>
-          <a:lstStyle/>
-          <a:p>
-            <a:pPr algn="l">
-              <a:lnSpc>
-                <a:spcPts val="2430"/>
-              </a:lnSpc>
-              <a:spcBef>
-                <a:spcPts val="0"/>
-              </a:spcBef>
-              <a:spcAft>
-                <a:spcPts val="0"/>
-              </a:spcAft>
-              <a:defRPr sz="1800" b="1">
-                <a:solidFill>
-                  <a:srgbClr val="142C42"/>
-                </a:solidFill>
-                <a:latin typeface="Microsoft JhengHei"/>
-              </a:defRPr>
-            </a:pPr>
-            <a:r>
-              <a:t>正式區：授權存取</a:t>
-            </a:r>
-          </a:p>
-        </p:txBody>
-      </p:sp>
-      <p:cxnSp>
-        <p:nvCxnSpPr>
-          <p:cNvPr id="16" name="Connector 15"/>
-          <p:cNvCxnSpPr/>
-          <p:nvPr/>
-        </p:nvCxnSpPr>
-        <p:spPr>
-          <a:xfrm>
-            <a:off x="2032000" y="3429000"/>
-            <a:ext cx="0" cy="190500"/>
-          </a:xfrm>
-          <a:prstGeom prst="line">
-            <a:avLst/>
-          </a:prstGeom>
-          <a:ln w="25400">
-            <a:solidFill>
-              <a:srgbClr val="087F8C"/>
-            </a:solidFill>
-            <a:tailEnd type="triangle" w="sm" len="sm"/>
-          </a:ln>
-        </p:spPr>
-        <p:style>
-          <a:lnRef idx="2">
-            <a:schemeClr val="accent1"/>
-          </a:lnRef>
-          <a:fillRef idx="0">
-            <a:schemeClr val="accent1"/>
-          </a:fillRef>
-          <a:effectRef idx="1">
-            <a:schemeClr val="accent1"/>
-          </a:effectRef>
-          <a:fontRef idx="minor">
-            <a:schemeClr val="tx1"/>
-          </a:fontRef>
-        </p:style>
-      </p:cxnSp>
-      <p:cxnSp>
-        <p:nvCxnSpPr>
-          <p:cNvPr id="17" name="Connector 16"/>
-          <p:cNvCxnSpPr/>
-          <p:nvPr/>
-        </p:nvCxnSpPr>
-        <p:spPr>
-          <a:xfrm>
-            <a:off x="2032000" y="4445000"/>
-            <a:ext cx="0" cy="317500"/>
-          </a:xfrm>
-          <a:prstGeom prst="line">
-            <a:avLst/>
-          </a:prstGeom>
-          <a:ln w="25400">
-            <a:solidFill>
-              <a:srgbClr val="087F8C"/>
-            </a:solidFill>
-            <a:tailEnd type="triangle" w="sm" len="sm"/>
-          </a:ln>
-        </p:spPr>
-        <p:style>
-          <a:lnRef idx="2">
-            <a:schemeClr val="accent1"/>
-          </a:lnRef>
-          <a:fillRef idx="0">
-            <a:schemeClr val="accent1"/>
-          </a:fillRef>
-          <a:effectRef idx="1">
-            <a:schemeClr val="accent1"/>
-          </a:effectRef>
-          <a:fontRef idx="minor">
-            <a:schemeClr val="tx1"/>
-          </a:fontRef>
-        </p:style>
-      </p:cxnSp>
-      <p:cxnSp>
-        <p:nvCxnSpPr>
-          <p:cNvPr id="18" name="Connector 17"/>
-          <p:cNvCxnSpPr/>
-          <p:nvPr/>
-        </p:nvCxnSpPr>
-        <p:spPr>
-          <a:xfrm flipV="1">
-            <a:off x="3302000" y="5168900"/>
-            <a:ext cx="127000" cy="6350"/>
-          </a:xfrm>
-          <a:prstGeom prst="line">
-            <a:avLst/>
-          </a:prstGeom>
-          <a:ln w="25400">
-            <a:solidFill>
-              <a:srgbClr val="087F8C"/>
-            </a:solidFill>
-          </a:ln>
-        </p:spPr>
-        <p:style>
-          <a:lnRef idx="2">
-            <a:schemeClr val="accent1"/>
-          </a:lnRef>
-          <a:fillRef idx="0">
-            <a:schemeClr val="accent1"/>
-          </a:fillRef>
-          <a:effectRef idx="1">
-            <a:schemeClr val="accent1"/>
-          </a:effectRef>
-          <a:fontRef idx="minor">
-            <a:schemeClr val="tx1"/>
-          </a:fontRef>
-        </p:style>
-      </p:cxnSp>
-      <p:cxnSp>
-        <p:nvCxnSpPr>
-          <p:cNvPr id="19" name="Connector 18"/>
-          <p:cNvCxnSpPr/>
-          <p:nvPr/>
-        </p:nvCxnSpPr>
-        <p:spPr>
-          <a:xfrm flipV="1">
-            <a:off x="3429000" y="4025900"/>
-            <a:ext cx="0" cy="1143000"/>
-          </a:xfrm>
-          <a:prstGeom prst="line">
-            <a:avLst/>
-          </a:prstGeom>
-          <a:ln w="25400">
-            <a:solidFill>
-              <a:srgbClr val="087F8C"/>
-            </a:solidFill>
-          </a:ln>
-        </p:spPr>
-        <p:style>
-          <a:lnRef idx="2">
-            <a:schemeClr val="accent1"/>
-          </a:lnRef>
-          <a:fillRef idx="0">
-            <a:schemeClr val="accent1"/>
-          </a:fillRef>
-          <a:effectRef idx="1">
-            <a:schemeClr val="accent1"/>
-          </a:effectRef>
-          <a:fontRef idx="minor">
-            <a:schemeClr val="tx1"/>
-          </a:fontRef>
-        </p:style>
-      </p:cxnSp>
-      <p:cxnSp>
-        <p:nvCxnSpPr>
-          <p:cNvPr id="20" name="Connector 19"/>
-          <p:cNvCxnSpPr/>
-          <p:nvPr/>
-        </p:nvCxnSpPr>
-        <p:spPr>
-          <a:xfrm flipH="1">
-            <a:off x="3302000" y="4025900"/>
-            <a:ext cx="127000" cy="6350"/>
-          </a:xfrm>
-          <a:prstGeom prst="line">
-            <a:avLst/>
-          </a:prstGeom>
-          <a:ln w="25400">
-            <a:solidFill>
-              <a:srgbClr val="087F8C"/>
-            </a:solidFill>
-            <a:tailEnd type="triangle" w="sm" len="sm"/>
-          </a:ln>
-        </p:spPr>
-        <p:style>
-          <a:lnRef idx="2">
-            <a:schemeClr val="accent1"/>
-          </a:lnRef>
-          <a:fillRef idx="0">
-            <a:schemeClr val="accent1"/>
-          </a:fillRef>
-          <a:effectRef idx="1">
-            <a:schemeClr val="accent1"/>
-          </a:effectRef>
-          <a:fontRef idx="minor">
-            <a:schemeClr val="tx1"/>
-          </a:fontRef>
-        </p:style>
-      </p:cxnSp>
-      <p:cxnSp>
-        <p:nvCxnSpPr>
-          <p:cNvPr id="21" name="Connector 20"/>
-          <p:cNvCxnSpPr/>
-          <p:nvPr/>
-        </p:nvCxnSpPr>
-        <p:spPr>
-          <a:xfrm flipV="1">
-            <a:off x="3302000" y="4025900"/>
-            <a:ext cx="444500" cy="6350"/>
-          </a:xfrm>
-          <a:prstGeom prst="line">
-            <a:avLst/>
-          </a:prstGeom>
-          <a:ln w="25400">
-            <a:solidFill>
-              <a:srgbClr val="087F8C"/>
-            </a:solidFill>
-          </a:ln>
-        </p:spPr>
-        <p:style>
-          <a:lnRef idx="2">
-            <a:schemeClr val="accent1"/>
-          </a:lnRef>
-          <a:fillRef idx="0">
-            <a:schemeClr val="accent1"/>
-          </a:fillRef>
-          <a:effectRef idx="1">
-            <a:schemeClr val="accent1"/>
-          </a:effectRef>
-          <a:fontRef idx="minor">
-            <a:schemeClr val="tx1"/>
-          </a:fontRef>
-        </p:style>
-      </p:cxnSp>
-      <p:cxnSp>
-        <p:nvCxnSpPr>
-          <p:cNvPr id="22" name="Connector 21"/>
-          <p:cNvCxnSpPr/>
-          <p:nvPr/>
-        </p:nvCxnSpPr>
-        <p:spPr>
-          <a:xfrm flipV="1">
-            <a:off x="3746500" y="3009900"/>
-            <a:ext cx="0" cy="1016000"/>
-          </a:xfrm>
-          <a:prstGeom prst="line">
-            <a:avLst/>
-          </a:prstGeom>
-          <a:ln w="25400">
-            <a:solidFill>
-              <a:srgbClr val="087F8C"/>
-            </a:solidFill>
-          </a:ln>
-        </p:spPr>
-        <p:style>
-          <a:lnRef idx="2">
-            <a:schemeClr val="accent1"/>
-          </a:lnRef>
-          <a:fillRef idx="0">
-            <a:schemeClr val="accent1"/>
-          </a:fillRef>
-          <a:effectRef idx="1">
-            <a:schemeClr val="accent1"/>
-          </a:effectRef>
-          <a:fontRef idx="minor">
-            <a:schemeClr val="tx1"/>
-          </a:fontRef>
-        </p:style>
-      </p:cxnSp>
-      <p:cxnSp>
-        <p:nvCxnSpPr>
-          <p:cNvPr id="23" name="Connector 22"/>
-          <p:cNvCxnSpPr/>
-          <p:nvPr/>
-        </p:nvCxnSpPr>
-        <p:spPr>
-          <a:xfrm>
-            <a:off x="3746500" y="3009900"/>
-            <a:ext cx="381000" cy="6350"/>
-          </a:xfrm>
-          <a:prstGeom prst="line">
-            <a:avLst/>
-          </a:prstGeom>
-          <a:ln w="25400">
-            <a:solidFill>
-              <a:srgbClr val="087F8C"/>
-            </a:solidFill>
-            <a:tailEnd type="triangle" w="sm" len="sm"/>
-          </a:ln>
-        </p:spPr>
-        <p:style>
-          <a:lnRef idx="2">
-            <a:schemeClr val="accent1"/>
-          </a:lnRef>
-          <a:fillRef idx="0">
-            <a:schemeClr val="accent1"/>
-          </a:fillRef>
-          <a:effectRef idx="1">
-            <a:schemeClr val="accent1"/>
-          </a:effectRef>
-          <a:fontRef idx="minor">
-            <a:schemeClr val="tx1"/>
-          </a:fontRef>
-        </p:style>
-      </p:cxnSp>
-      <p:cxnSp>
-        <p:nvCxnSpPr>
-          <p:cNvPr id="24" name="Connector 23"/>
-          <p:cNvCxnSpPr/>
-          <p:nvPr/>
-        </p:nvCxnSpPr>
-        <p:spPr>
-          <a:xfrm>
-            <a:off x="6350000" y="3016250"/>
-            <a:ext cx="127000" cy="0"/>
-          </a:xfrm>
-          <a:prstGeom prst="line">
-            <a:avLst/>
-          </a:prstGeom>
-          <a:ln w="25400">
-            <a:solidFill>
-              <a:srgbClr val="087F8C"/>
-            </a:solidFill>
-          </a:ln>
-        </p:spPr>
-        <p:style>
-          <a:lnRef idx="2">
-            <a:schemeClr val="accent1"/>
-          </a:lnRef>
-          <a:fillRef idx="0">
-            <a:schemeClr val="accent1"/>
-          </a:fillRef>
-          <a:effectRef idx="1">
-            <a:schemeClr val="accent1"/>
-          </a:effectRef>
-          <a:fontRef idx="minor">
-            <a:schemeClr val="tx1"/>
-          </a:fontRef>
-        </p:style>
-      </p:cxnSp>
-      <p:cxnSp>
-        <p:nvCxnSpPr>
-          <p:cNvPr id="25" name="Connector 24"/>
-          <p:cNvCxnSpPr/>
-          <p:nvPr/>
-        </p:nvCxnSpPr>
-        <p:spPr>
-          <a:xfrm>
-            <a:off x="6477000" y="3016250"/>
-            <a:ext cx="0" cy="190500"/>
-          </a:xfrm>
-          <a:prstGeom prst="line">
-            <a:avLst/>
-          </a:prstGeom>
-          <a:ln w="25400">
-            <a:solidFill>
-              <a:srgbClr val="087F8C"/>
-            </a:solidFill>
-          </a:ln>
-        </p:spPr>
-        <p:style>
-          <a:lnRef idx="2">
-            <a:schemeClr val="accent1"/>
-          </a:lnRef>
-          <a:fillRef idx="0">
-            <a:schemeClr val="accent1"/>
-          </a:fillRef>
-          <a:effectRef idx="1">
-            <a:schemeClr val="accent1"/>
-          </a:effectRef>
-          <a:fontRef idx="minor">
-            <a:schemeClr val="tx1"/>
-          </a:fontRef>
-        </p:style>
-      </p:cxnSp>
-      <p:cxnSp>
-        <p:nvCxnSpPr>
-          <p:cNvPr id="26" name="Connector 25"/>
-          <p:cNvCxnSpPr/>
-          <p:nvPr/>
-        </p:nvCxnSpPr>
-        <p:spPr>
-          <a:xfrm>
-            <a:off x="6477000" y="3206750"/>
-            <a:ext cx="127000" cy="0"/>
-          </a:xfrm>
-          <a:prstGeom prst="line">
-            <a:avLst/>
-          </a:prstGeom>
-          <a:ln w="25400">
-            <a:solidFill>
-              <a:srgbClr val="087F8C"/>
-            </a:solidFill>
-            <a:tailEnd type="triangle" w="sm" len="sm"/>
-          </a:ln>
-        </p:spPr>
-        <p:style>
-          <a:lnRef idx="2">
-            <a:schemeClr val="accent1"/>
-          </a:lnRef>
-          <a:fillRef idx="0">
-            <a:schemeClr val="accent1"/>
-          </a:fillRef>
-          <a:effectRef idx="1">
-            <a:schemeClr val="accent1"/>
-          </a:effectRef>
-          <a:fontRef idx="minor">
-            <a:schemeClr val="tx1"/>
-          </a:fontRef>
-        </p:style>
-      </p:cxnSp>
-      <p:cxnSp>
-        <p:nvCxnSpPr>
-          <p:cNvPr id="27" name="Connector 26"/>
-          <p:cNvCxnSpPr/>
-          <p:nvPr/>
-        </p:nvCxnSpPr>
-        <p:spPr>
-          <a:xfrm flipV="1">
-            <a:off x="3302000" y="4025900"/>
-            <a:ext cx="317500" cy="6350"/>
-          </a:xfrm>
-          <a:prstGeom prst="line">
-            <a:avLst/>
-          </a:prstGeom>
-          <a:ln w="25400">
-            <a:solidFill>
-              <a:srgbClr val="087F8C"/>
-            </a:solidFill>
-          </a:ln>
-        </p:spPr>
-        <p:style>
-          <a:lnRef idx="2">
-            <a:schemeClr val="accent1"/>
-          </a:lnRef>
-          <a:fillRef idx="0">
-            <a:schemeClr val="accent1"/>
-          </a:fillRef>
-          <a:effectRef idx="1">
-            <a:schemeClr val="accent1"/>
-          </a:effectRef>
-          <a:fontRef idx="minor">
-            <a:schemeClr val="tx1"/>
-          </a:fontRef>
-        </p:style>
-      </p:cxnSp>
-      <p:cxnSp>
-        <p:nvCxnSpPr>
-          <p:cNvPr id="28" name="Connector 27"/>
-          <p:cNvCxnSpPr/>
-          <p:nvPr/>
-        </p:nvCxnSpPr>
-        <p:spPr>
-          <a:xfrm>
-            <a:off x="3619500" y="4025900"/>
-            <a:ext cx="0" cy="1079500"/>
-          </a:xfrm>
-          <a:prstGeom prst="line">
-            <a:avLst/>
-          </a:prstGeom>
-          <a:ln w="25400">
-            <a:solidFill>
-              <a:srgbClr val="087F8C"/>
-            </a:solidFill>
-          </a:ln>
-        </p:spPr>
-        <p:style>
-          <a:lnRef idx="2">
-            <a:schemeClr val="accent1"/>
-          </a:lnRef>
-          <a:fillRef idx="0">
-            <a:schemeClr val="accent1"/>
-          </a:fillRef>
-          <a:effectRef idx="1">
-            <a:schemeClr val="accent1"/>
-          </a:effectRef>
-          <a:fontRef idx="minor">
-            <a:schemeClr val="tx1"/>
-          </a:fontRef>
-        </p:style>
-      </p:cxnSp>
-      <p:cxnSp>
-        <p:nvCxnSpPr>
-          <p:cNvPr id="29" name="Connector 28"/>
-          <p:cNvCxnSpPr/>
-          <p:nvPr/>
-        </p:nvCxnSpPr>
-        <p:spPr>
-          <a:xfrm>
-            <a:off x="3619500" y="5105400"/>
-            <a:ext cx="508000" cy="6350"/>
-          </a:xfrm>
-          <a:prstGeom prst="line">
-            <a:avLst/>
-          </a:prstGeom>
-          <a:ln w="25400">
-            <a:solidFill>
-              <a:srgbClr val="087F8C"/>
-            </a:solidFill>
-            <a:tailEnd type="triangle" w="sm" len="sm"/>
-          </a:ln>
-        </p:spPr>
-        <p:style>
-          <a:lnRef idx="2">
-            <a:schemeClr val="accent1"/>
-          </a:lnRef>
-          <a:fillRef idx="0">
-            <a:schemeClr val="accent1"/>
-          </a:fillRef>
-          <a:effectRef idx="1">
-            <a:schemeClr val="accent1"/>
-          </a:effectRef>
-          <a:fontRef idx="minor">
-            <a:schemeClr val="tx1"/>
-          </a:fontRef>
-        </p:style>
-      </p:cxnSp>
-      <p:cxnSp>
-        <p:nvCxnSpPr>
-          <p:cNvPr id="30" name="Connector 29"/>
-          <p:cNvCxnSpPr/>
-          <p:nvPr/>
-        </p:nvCxnSpPr>
-        <p:spPr>
-          <a:xfrm flipH="1">
-            <a:off x="7645400" y="3810000"/>
-            <a:ext cx="6350" cy="381000"/>
-          </a:xfrm>
-          <a:prstGeom prst="line">
-            <a:avLst/>
-          </a:prstGeom>
-          <a:ln w="25400">
-            <a:solidFill>
-              <a:srgbClr val="087F8C"/>
-            </a:solidFill>
-          </a:ln>
-        </p:spPr>
-        <p:style>
-          <a:lnRef idx="2">
-            <a:schemeClr val="accent1"/>
-          </a:lnRef>
-          <a:fillRef idx="0">
-            <a:schemeClr val="accent1"/>
-          </a:fillRef>
-          <a:effectRef idx="1">
-            <a:schemeClr val="accent1"/>
-          </a:effectRef>
-          <a:fontRef idx="minor">
-            <a:schemeClr val="tx1"/>
-          </a:fontRef>
-        </p:style>
-      </p:cxnSp>
-      <p:cxnSp>
-        <p:nvCxnSpPr>
-          <p:cNvPr id="31" name="Connector 30"/>
-          <p:cNvCxnSpPr/>
-          <p:nvPr/>
-        </p:nvCxnSpPr>
-        <p:spPr>
-          <a:xfrm flipH="1">
-            <a:off x="6477000" y="4191000"/>
-            <a:ext cx="1168400" cy="0"/>
-          </a:xfrm>
-          <a:prstGeom prst="line">
-            <a:avLst/>
-          </a:prstGeom>
-          <a:ln w="25400">
-            <a:solidFill>
-              <a:srgbClr val="087F8C"/>
-            </a:solidFill>
-          </a:ln>
-        </p:spPr>
-        <p:style>
-          <a:lnRef idx="2">
-            <a:schemeClr val="accent1"/>
-          </a:lnRef>
-          <a:fillRef idx="0">
-            <a:schemeClr val="accent1"/>
-          </a:fillRef>
-          <a:effectRef idx="1">
-            <a:schemeClr val="accent1"/>
-          </a:effectRef>
-          <a:fontRef idx="minor">
-            <a:schemeClr val="tx1"/>
-          </a:fontRef>
-        </p:style>
-      </p:cxnSp>
-      <p:cxnSp>
-        <p:nvCxnSpPr>
-          <p:cNvPr id="32" name="Connector 31"/>
-          <p:cNvCxnSpPr/>
-          <p:nvPr/>
-        </p:nvCxnSpPr>
-        <p:spPr>
-          <a:xfrm>
-            <a:off x="6477000" y="4191000"/>
-            <a:ext cx="0" cy="914400"/>
-          </a:xfrm>
-          <a:prstGeom prst="line">
-            <a:avLst/>
-          </a:prstGeom>
-          <a:ln w="25400">
-            <a:solidFill>
-              <a:srgbClr val="087F8C"/>
-            </a:solidFill>
-          </a:ln>
-        </p:spPr>
-        <p:style>
-          <a:lnRef idx="2">
-            <a:schemeClr val="accent1"/>
-          </a:lnRef>
-          <a:fillRef idx="0">
-            <a:schemeClr val="accent1"/>
-          </a:fillRef>
-          <a:effectRef idx="1">
-            <a:schemeClr val="accent1"/>
-          </a:effectRef>
-          <a:fontRef idx="minor">
-            <a:schemeClr val="tx1"/>
-          </a:fontRef>
-        </p:style>
-      </p:cxnSp>
-      <p:cxnSp>
-        <p:nvCxnSpPr>
-          <p:cNvPr id="33" name="Connector 32"/>
-          <p:cNvCxnSpPr/>
-          <p:nvPr/>
-        </p:nvCxnSpPr>
-        <p:spPr>
-          <a:xfrm flipH="1">
-            <a:off x="6350000" y="5105400"/>
-            <a:ext cx="127000" cy="6350"/>
-          </a:xfrm>
-          <a:prstGeom prst="line">
-            <a:avLst/>
-          </a:prstGeom>
-          <a:ln w="25400">
-            <a:solidFill>
-              <a:srgbClr val="087F8C"/>
-            </a:solidFill>
-            <a:tailEnd type="triangle" w="sm" len="sm"/>
-          </a:ln>
-        </p:spPr>
-        <p:style>
-          <a:lnRef idx="2">
-            <a:schemeClr val="accent1"/>
-          </a:lnRef>
-          <a:fillRef idx="0">
-            <a:schemeClr val="accent1"/>
-          </a:fillRef>
-          <a:effectRef idx="1">
-            <a:schemeClr val="accent1"/>
-          </a:effectRef>
-          <a:fontRef idx="minor">
-            <a:schemeClr val="tx1"/>
-          </a:fontRef>
-        </p:style>
-      </p:cxnSp>
-      <p:cxnSp>
-        <p:nvCxnSpPr>
-          <p:cNvPr id="34" name="Connector 33"/>
-          <p:cNvCxnSpPr/>
-          <p:nvPr/>
-        </p:nvCxnSpPr>
-        <p:spPr>
-          <a:xfrm flipH="1" flipV="1">
-            <a:off x="5232400" y="4000500"/>
-            <a:ext cx="6350" cy="635000"/>
-          </a:xfrm>
-          <a:prstGeom prst="line">
-            <a:avLst/>
-          </a:prstGeom>
-          <a:ln w="25400">
-            <a:solidFill>
-              <a:srgbClr val="087F8C"/>
-            </a:solidFill>
-          </a:ln>
-        </p:spPr>
-        <p:style>
-          <a:lnRef idx="2">
-            <a:schemeClr val="accent1"/>
-          </a:lnRef>
-          <a:fillRef idx="0">
-            <a:schemeClr val="accent1"/>
-          </a:fillRef>
-          <a:effectRef idx="1">
-            <a:schemeClr val="accent1"/>
-          </a:effectRef>
-          <a:fontRef idx="minor">
-            <a:schemeClr val="tx1"/>
-          </a:fontRef>
-        </p:style>
-      </p:cxnSp>
-      <p:cxnSp>
-        <p:nvCxnSpPr>
-          <p:cNvPr id="35" name="Connector 34"/>
-          <p:cNvCxnSpPr/>
-          <p:nvPr/>
-        </p:nvCxnSpPr>
-        <p:spPr>
-          <a:xfrm>
-            <a:off x="5232400" y="4000500"/>
-            <a:ext cx="1181100" cy="0"/>
-          </a:xfrm>
-          <a:prstGeom prst="line">
-            <a:avLst/>
-          </a:prstGeom>
-          <a:ln w="25400">
-            <a:solidFill>
-              <a:srgbClr val="087F8C"/>
-            </a:solidFill>
-          </a:ln>
-        </p:spPr>
-        <p:style>
-          <a:lnRef idx="2">
-            <a:schemeClr val="accent1"/>
-          </a:lnRef>
-          <a:fillRef idx="0">
-            <a:schemeClr val="accent1"/>
-          </a:fillRef>
-          <a:effectRef idx="1">
-            <a:schemeClr val="accent1"/>
-          </a:effectRef>
-          <a:fontRef idx="minor">
-            <a:schemeClr val="tx1"/>
-          </a:fontRef>
-        </p:style>
-      </p:cxnSp>
-      <p:cxnSp>
-        <p:nvCxnSpPr>
-          <p:cNvPr id="36" name="Connector 35"/>
-          <p:cNvCxnSpPr/>
-          <p:nvPr/>
-        </p:nvCxnSpPr>
-        <p:spPr>
-          <a:xfrm flipV="1">
-            <a:off x="6413500" y="3200400"/>
-            <a:ext cx="0" cy="800100"/>
-          </a:xfrm>
-          <a:prstGeom prst="line">
-            <a:avLst/>
-          </a:prstGeom>
-          <a:ln w="25400">
-            <a:solidFill>
-              <a:srgbClr val="087F8C"/>
-            </a:solidFill>
-          </a:ln>
-        </p:spPr>
-        <p:style>
-          <a:lnRef idx="2">
-            <a:schemeClr val="accent1"/>
-          </a:lnRef>
-          <a:fillRef idx="0">
-            <a:schemeClr val="accent1"/>
-          </a:fillRef>
-          <a:effectRef idx="1">
-            <a:schemeClr val="accent1"/>
-          </a:effectRef>
-          <a:fontRef idx="minor">
-            <a:schemeClr val="tx1"/>
-          </a:fontRef>
-        </p:style>
-      </p:cxnSp>
-      <p:cxnSp>
-        <p:nvCxnSpPr>
-          <p:cNvPr id="37" name="Connector 36"/>
-          <p:cNvCxnSpPr/>
-          <p:nvPr/>
-        </p:nvCxnSpPr>
-        <p:spPr>
-          <a:xfrm>
-            <a:off x="6413500" y="3200400"/>
-            <a:ext cx="190500" cy="6350"/>
-          </a:xfrm>
-          <a:prstGeom prst="line">
-            <a:avLst/>
-          </a:prstGeom>
-          <a:ln w="25400">
-            <a:solidFill>
-              <a:srgbClr val="087F8C"/>
-            </a:solidFill>
-            <a:tailEnd type="triangle" w="sm" len="sm"/>
-          </a:ln>
-        </p:spPr>
-        <p:style>
-          <a:lnRef idx="2">
-            <a:schemeClr val="accent1"/>
-          </a:lnRef>
-          <a:fillRef idx="0">
-            <a:schemeClr val="accent1"/>
-          </a:fillRef>
-          <a:effectRef idx="1">
-            <a:schemeClr val="accent1"/>
-          </a:effectRef>
-          <a:fontRef idx="minor">
-            <a:schemeClr val="tx1"/>
-          </a:fontRef>
-        </p:style>
-      </p:cxnSp>
-      <p:cxnSp>
-        <p:nvCxnSpPr>
-          <p:cNvPr id="38" name="Connector 37"/>
-          <p:cNvCxnSpPr/>
-          <p:nvPr/>
-        </p:nvCxnSpPr>
-        <p:spPr>
-          <a:xfrm flipV="1">
-            <a:off x="7651750" y="3810000"/>
-            <a:ext cx="0" cy="825500"/>
-          </a:xfrm>
-          <a:prstGeom prst="line">
-            <a:avLst/>
-          </a:prstGeom>
-          <a:ln w="25400">
-            <a:solidFill>
-              <a:srgbClr val="087F8C"/>
-            </a:solidFill>
-            <a:tailEnd type="triangle" w="sm" len="sm"/>
-          </a:ln>
-        </p:spPr>
-        <p:style>
-          <a:lnRef idx="2">
-            <a:schemeClr val="accent1"/>
-          </a:lnRef>
-          <a:fillRef idx="0">
-            <a:schemeClr val="accent1"/>
-          </a:fillRef>
-          <a:effectRef idx="1">
-            <a:schemeClr val="accent1"/>
-          </a:effectRef>
-          <a:fontRef idx="minor">
-            <a:schemeClr val="tx1"/>
-          </a:fontRef>
-        </p:style>
-      </p:cxnSp>
-      <p:cxnSp>
-        <p:nvCxnSpPr>
-          <p:cNvPr id="39" name="Connector 38"/>
-          <p:cNvCxnSpPr/>
-          <p:nvPr/>
-        </p:nvCxnSpPr>
-        <p:spPr>
-          <a:xfrm>
-            <a:off x="8699500" y="3206750"/>
-            <a:ext cx="762000" cy="0"/>
-          </a:xfrm>
-          <a:prstGeom prst="line">
-            <a:avLst/>
-          </a:prstGeom>
-          <a:ln w="25400">
-            <a:solidFill>
-              <a:srgbClr val="087F8C"/>
-            </a:solidFill>
-            <a:tailEnd type="triangle" w="sm" len="sm"/>
-          </a:ln>
-        </p:spPr>
-        <p:style>
-          <a:lnRef idx="2">
-            <a:schemeClr val="accent1"/>
-          </a:lnRef>
-          <a:fillRef idx="0">
-            <a:schemeClr val="accent1"/>
-          </a:fillRef>
-          <a:effectRef idx="1">
-            <a:schemeClr val="accent1"/>
-          </a:effectRef>
-          <a:fontRef idx="minor">
-            <a:schemeClr val="tx1"/>
-          </a:fontRef>
-        </p:style>
-      </p:cxnSp>
-      <p:cxnSp>
-        <p:nvCxnSpPr>
-          <p:cNvPr id="40" name="Connector 39"/>
-          <p:cNvCxnSpPr/>
-          <p:nvPr/>
-        </p:nvCxnSpPr>
-        <p:spPr>
-          <a:xfrm>
-            <a:off x="10477500" y="3810000"/>
-            <a:ext cx="0" cy="825500"/>
-          </a:xfrm>
-          <a:prstGeom prst="line">
-            <a:avLst/>
-          </a:prstGeom>
-          <a:ln w="25400">
-            <a:solidFill>
-              <a:srgbClr val="087F8C"/>
-            </a:solidFill>
-            <a:tailEnd type="triangle" w="sm" len="sm"/>
-          </a:ln>
-        </p:spPr>
-        <p:style>
-          <a:lnRef idx="2">
-            <a:schemeClr val="accent1"/>
-          </a:lnRef>
-          <a:fillRef idx="0">
-            <a:schemeClr val="accent1"/>
-          </a:fillRef>
-          <a:effectRef idx="1">
-            <a:schemeClr val="accent1"/>
-          </a:effectRef>
-          <a:fontRef idx="minor">
-            <a:schemeClr val="tx1"/>
-          </a:fontRef>
-        </p:style>
-      </p:cxnSp>
-      <p:sp>
-        <p:nvSpPr>
-          <p:cNvPr id="41" name="Rounded Rectangle 40" descr="① 開發人員&#10;推送程式碼"/>
-          <p:cNvSpPr/>
-          <p:nvPr/>
-        </p:nvSpPr>
-        <p:spPr>
-          <a:xfrm>
-            <a:off x="762000" y="2603500"/>
-            <a:ext cx="2540000" cy="825500"/>
-          </a:xfrm>
-          <a:prstGeom prst="roundRect">
-            <a:avLst>
-              <a:gd name="adj" fmla="val 8000"/>
-            </a:avLst>
-          </a:prstGeom>
-          <a:solidFill>
-            <a:srgbClr val="FFF1DA"/>
-          </a:solidFill>
-          <a:ln w="10160">
-            <a:solidFill>
-              <a:srgbClr val="C57227"/>
-            </a:solidFill>
-          </a:ln>
-        </p:spPr>
-        <p:style>
-          <a:lnRef idx="1">
-            <a:schemeClr val="accent1"/>
-          </a:lnRef>
-          <a:fillRef idx="3">
-            <a:schemeClr val="accent1"/>
-          </a:fillRef>
-          <a:effectRef idx="2">
-            <a:schemeClr val="accent1"/>
-          </a:effectRef>
-          <a:fontRef idx="minor">
-            <a:schemeClr val="lt1"/>
-          </a:fontRef>
-        </p:style>
-        <p:txBody>
-          <a:bodyPr rtlCol="0" anchor="ctr"/>
-          <a:lstStyle/>
-          <a:p>
-            <a:pPr algn="ctr"/>
-          </a:p>
-        </p:txBody>
-      </p:sp>
-      <p:sp>
-        <p:nvSpPr>
-          <p:cNvPr id="42" name="TextBox 41"/>
-          <p:cNvSpPr txBox="1"/>
-          <p:nvPr/>
-        </p:nvSpPr>
-        <p:spPr>
-          <a:xfrm>
-            <a:off x="901700" y="2686367"/>
-            <a:ext cx="2260600" cy="659765"/>
-          </a:xfrm>
-          <a:prstGeom prst="rect">
-            <a:avLst/>
-          </a:prstGeom>
-          <a:noFill/>
-        </p:spPr>
-        <p:txBody>
-          <a:bodyPr wrap="none" lIns="0" rIns="0" tIns="0" bIns="0" anchor="t">
-            <a:spAutoFit/>
-          </a:bodyPr>
-          <a:lstStyle/>
-          <a:p>
-            <a:pPr algn="ctr">
-              <a:lnSpc>
-                <a:spcPts val="2497"/>
-              </a:lnSpc>
-              <a:spcBef>
-                <a:spcPts val="0"/>
-              </a:spcBef>
-              <a:spcAft>
-                <a:spcPts val="0"/>
-              </a:spcAft>
-              <a:defRPr sz="1850" b="1">
-                <a:solidFill>
-                  <a:srgbClr val="754519"/>
-                </a:solidFill>
-                <a:latin typeface="Microsoft JhengHei"/>
-              </a:defRPr>
-            </a:pPr>
-            <a:r>
-              <a:t>① 開發人員</a:t>
-            </a:r>
-          </a:p>
-          <a:p>
-            <a:pPr algn="ctr">
-              <a:lnSpc>
-                <a:spcPts val="2497"/>
-              </a:lnSpc>
-              <a:spcBef>
-                <a:spcPts val="0"/>
-              </a:spcBef>
-              <a:spcAft>
-                <a:spcPts val="0"/>
-              </a:spcAft>
-              <a:defRPr sz="1850" b="1">
-                <a:solidFill>
-                  <a:srgbClr val="754519"/>
-                </a:solidFill>
-                <a:latin typeface="Microsoft JhengHei"/>
-              </a:defRPr>
-            </a:pPr>
-            <a:r>
-              <a:t>推送程式碼</a:t>
-            </a:r>
-          </a:p>
-        </p:txBody>
-      </p:sp>
-      <p:sp>
-        <p:nvSpPr>
-          <p:cNvPr id="43" name="Rounded Rectangle 42" descr="GitLab CE&#10;派工／保存產物"/>
-          <p:cNvSpPr/>
-          <p:nvPr/>
-        </p:nvSpPr>
-        <p:spPr>
-          <a:xfrm>
-            <a:off x="762000" y="3619500"/>
-            <a:ext cx="2540000" cy="825500"/>
-          </a:xfrm>
-          <a:prstGeom prst="roundRect">
-            <a:avLst>
-              <a:gd name="adj" fmla="val 8000"/>
-            </a:avLst>
-          </a:prstGeom>
-          <a:solidFill>
-            <a:srgbClr val="142C42"/>
-          </a:solidFill>
-          <a:ln w="10160">
-            <a:solidFill>
-              <a:srgbClr val="142C42"/>
-            </a:solidFill>
-          </a:ln>
-        </p:spPr>
-        <p:style>
-          <a:lnRef idx="1">
-            <a:schemeClr val="accent1"/>
-          </a:lnRef>
-          <a:fillRef idx="3">
-            <a:schemeClr val="accent1"/>
-          </a:fillRef>
-          <a:effectRef idx="2">
-            <a:schemeClr val="accent1"/>
-          </a:effectRef>
-          <a:fontRef idx="minor">
-            <a:schemeClr val="lt1"/>
-          </a:fontRef>
-        </p:style>
-        <p:txBody>
-          <a:bodyPr rtlCol="0" anchor="ctr"/>
-          <a:lstStyle/>
-          <a:p>
-            <a:pPr algn="ctr"/>
-          </a:p>
-        </p:txBody>
-      </p:sp>
-      <p:sp>
-        <p:nvSpPr>
-          <p:cNvPr id="44" name="TextBox 43"/>
-          <p:cNvSpPr txBox="1"/>
-          <p:nvPr/>
-        </p:nvSpPr>
-        <p:spPr>
-          <a:xfrm>
-            <a:off x="901700" y="3702367"/>
-            <a:ext cx="2260600" cy="659765"/>
-          </a:xfrm>
-          <a:prstGeom prst="rect">
-            <a:avLst/>
-          </a:prstGeom>
-          <a:noFill/>
-        </p:spPr>
-        <p:txBody>
-          <a:bodyPr wrap="none" lIns="0" rIns="0" tIns="0" bIns="0" anchor="t">
-            <a:spAutoFit/>
-          </a:bodyPr>
-          <a:lstStyle/>
-          <a:p>
-            <a:pPr algn="ctr">
-              <a:lnSpc>
-                <a:spcPts val="2497"/>
-              </a:lnSpc>
-              <a:spcBef>
-                <a:spcPts val="0"/>
-              </a:spcBef>
-              <a:spcAft>
-                <a:spcPts val="0"/>
-              </a:spcAft>
-              <a:defRPr sz="1850" b="1">
-                <a:solidFill>
-                  <a:srgbClr val="FFFFFF"/>
-                </a:solidFill>
-                <a:latin typeface="Microsoft JhengHei"/>
-              </a:defRPr>
-            </a:pPr>
-            <a:r>
-              <a:t>GitLab CE</a:t>
-            </a:r>
-          </a:p>
-          <a:p>
-            <a:pPr algn="ctr">
-              <a:lnSpc>
-                <a:spcPts val="2497"/>
-              </a:lnSpc>
-              <a:spcBef>
-                <a:spcPts val="0"/>
-              </a:spcBef>
-              <a:spcAft>
-                <a:spcPts val="0"/>
-              </a:spcAft>
-              <a:defRPr sz="1850" b="1">
-                <a:solidFill>
-                  <a:srgbClr val="FFFFFF"/>
-                </a:solidFill>
-                <a:latin typeface="Microsoft JhengHei"/>
-              </a:defRPr>
-            </a:pPr>
-            <a:r>
-              <a:t>派工／保存產物</a:t>
-            </a:r>
-          </a:p>
-        </p:txBody>
-      </p:sp>
-      <p:sp>
-        <p:nvSpPr>
-          <p:cNvPr id="45" name="Rounded Rectangle 44" descr="GitLab Runner&#10;建置／測試"/>
-          <p:cNvSpPr/>
-          <p:nvPr/>
-        </p:nvSpPr>
-        <p:spPr>
-          <a:xfrm>
-            <a:off x="762000" y="4762500"/>
-            <a:ext cx="2540000" cy="825500"/>
-          </a:xfrm>
-          <a:prstGeom prst="roundRect">
-            <a:avLst>
-              <a:gd name="adj" fmla="val 8000"/>
-            </a:avLst>
-          </a:prstGeom>
-          <a:solidFill>
-            <a:srgbClr val="142C42"/>
-          </a:solidFill>
-          <a:ln w="10160">
-            <a:solidFill>
-              <a:srgbClr val="142C42"/>
-            </a:solidFill>
-          </a:ln>
-        </p:spPr>
-        <p:style>
-          <a:lnRef idx="1">
-            <a:schemeClr val="accent1"/>
-          </a:lnRef>
-          <a:fillRef idx="3">
-            <a:schemeClr val="accent1"/>
-          </a:fillRef>
-          <a:effectRef idx="2">
-            <a:schemeClr val="accent1"/>
-          </a:effectRef>
-          <a:fontRef idx="minor">
-            <a:schemeClr val="lt1"/>
-          </a:fontRef>
-        </p:style>
-        <p:txBody>
-          <a:bodyPr rtlCol="0" anchor="ctr"/>
-          <a:lstStyle/>
-          <a:p>
-            <a:pPr algn="ctr"/>
-          </a:p>
-        </p:txBody>
-      </p:sp>
-      <p:sp>
-        <p:nvSpPr>
-          <p:cNvPr id="46" name="TextBox 45"/>
-          <p:cNvSpPr txBox="1"/>
-          <p:nvPr/>
-        </p:nvSpPr>
-        <p:spPr>
-          <a:xfrm>
-            <a:off x="901700" y="4845367"/>
-            <a:ext cx="2260600" cy="659765"/>
-          </a:xfrm>
-          <a:prstGeom prst="rect">
-            <a:avLst/>
-          </a:prstGeom>
-          <a:noFill/>
-        </p:spPr>
-        <p:txBody>
-          <a:bodyPr wrap="none" lIns="0" rIns="0" tIns="0" bIns="0" anchor="t">
-            <a:spAutoFit/>
-          </a:bodyPr>
-          <a:lstStyle/>
-          <a:p>
-            <a:pPr algn="ctr">
-              <a:lnSpc>
-                <a:spcPts val="2497"/>
-              </a:lnSpc>
-              <a:spcBef>
-                <a:spcPts val="0"/>
-              </a:spcBef>
-              <a:spcAft>
-                <a:spcPts val="0"/>
-              </a:spcAft>
-              <a:defRPr sz="1850" b="1">
-                <a:solidFill>
-                  <a:srgbClr val="FFFFFF"/>
-                </a:solidFill>
-                <a:latin typeface="Microsoft JhengHei"/>
-              </a:defRPr>
-            </a:pPr>
-            <a:r>
-              <a:t>GitLab Runner</a:t>
-            </a:r>
-          </a:p>
-          <a:p>
-            <a:pPr algn="ctr">
-              <a:lnSpc>
-                <a:spcPts val="2497"/>
-              </a:lnSpc>
-              <a:spcBef>
-                <a:spcPts val="0"/>
-              </a:spcBef>
-              <a:spcAft>
-                <a:spcPts val="0"/>
-              </a:spcAft>
-              <a:defRPr sz="1850" b="1">
-                <a:solidFill>
-                  <a:srgbClr val="FFFFFF"/>
-                </a:solidFill>
-                <a:latin typeface="Microsoft JhengHei"/>
-              </a:defRPr>
-            </a:pPr>
-            <a:r>
-              <a:t>建置／測試</a:t>
-            </a:r>
-          </a:p>
-        </p:txBody>
-      </p:sp>
-      <p:sp>
-        <p:nvSpPr>
-          <p:cNvPr id="47" name="Rounded Rectangle 46" descr="② 事件接收器&#10;驗證成功通知"/>
-          <p:cNvSpPr/>
-          <p:nvPr/>
-        </p:nvSpPr>
-        <p:spPr>
-          <a:xfrm>
-            <a:off x="4127500" y="2603500"/>
-            <a:ext cx="2222500" cy="825500"/>
-          </a:xfrm>
-          <a:prstGeom prst="roundRect">
-            <a:avLst>
-              <a:gd name="adj" fmla="val 8000"/>
-            </a:avLst>
-          </a:prstGeom>
-          <a:solidFill>
-            <a:srgbClr val="142C42"/>
-          </a:solidFill>
-          <a:ln w="10160">
-            <a:solidFill>
-              <a:srgbClr val="142C42"/>
-            </a:solidFill>
-          </a:ln>
-        </p:spPr>
-        <p:style>
-          <a:lnRef idx="1">
-            <a:schemeClr val="accent1"/>
-          </a:lnRef>
-          <a:fillRef idx="3">
-            <a:schemeClr val="accent1"/>
-          </a:fillRef>
-          <a:effectRef idx="2">
-            <a:schemeClr val="accent1"/>
-          </a:effectRef>
-          <a:fontRef idx="minor">
-            <a:schemeClr val="lt1"/>
-          </a:fontRef>
-        </p:style>
-        <p:txBody>
-          <a:bodyPr rtlCol="0" anchor="ctr"/>
-          <a:lstStyle/>
-          <a:p>
-            <a:pPr algn="ctr"/>
-          </a:p>
-        </p:txBody>
-      </p:sp>
-      <p:sp>
-        <p:nvSpPr>
-          <p:cNvPr id="48" name="TextBox 47"/>
-          <p:cNvSpPr txBox="1"/>
-          <p:nvPr/>
-        </p:nvSpPr>
-        <p:spPr>
-          <a:xfrm>
-            <a:off x="4267200" y="2686367"/>
-            <a:ext cx="1943100" cy="659765"/>
-          </a:xfrm>
-          <a:prstGeom prst="rect">
-            <a:avLst/>
-          </a:prstGeom>
-          <a:noFill/>
-        </p:spPr>
-        <p:txBody>
-          <a:bodyPr wrap="none" lIns="0" rIns="0" tIns="0" bIns="0" anchor="t">
-            <a:spAutoFit/>
-          </a:bodyPr>
-          <a:lstStyle/>
-          <a:p>
-            <a:pPr algn="ctr">
-              <a:lnSpc>
-                <a:spcPts val="2497"/>
-              </a:lnSpc>
-              <a:spcBef>
-                <a:spcPts val="0"/>
-              </a:spcBef>
-              <a:spcAft>
-                <a:spcPts val="0"/>
-              </a:spcAft>
-              <a:defRPr sz="1850" b="1">
-                <a:solidFill>
-                  <a:srgbClr val="FFFFFF"/>
-                </a:solidFill>
-                <a:latin typeface="Microsoft JhengHei"/>
-              </a:defRPr>
-            </a:pPr>
-            <a:r>
-              <a:t>② 事件接收器</a:t>
-            </a:r>
-          </a:p>
-          <a:p>
-            <a:pPr algn="ctr">
-              <a:lnSpc>
-                <a:spcPts val="2497"/>
-              </a:lnSpc>
-              <a:spcBef>
-                <a:spcPts val="0"/>
-              </a:spcBef>
-              <a:spcAft>
-                <a:spcPts val="0"/>
-              </a:spcAft>
-              <a:defRPr sz="1850" b="1">
-                <a:solidFill>
-                  <a:srgbClr val="FFFFFF"/>
-                </a:solidFill>
-                <a:latin typeface="Microsoft JhengHei"/>
-              </a:defRPr>
-            </a:pPr>
-            <a:r>
-              <a:t>驗證成功通知</a:t>
-            </a:r>
-          </a:p>
-        </p:txBody>
-      </p:sp>
-      <p:sp>
-        <p:nvSpPr>
-          <p:cNvPr id="49" name="Rounded Rectangle 48" descr="ADO Server&#10;排程／存版本&#10;管理 Release"/>
-          <p:cNvSpPr/>
-          <p:nvPr/>
-        </p:nvSpPr>
-        <p:spPr>
-          <a:xfrm>
-            <a:off x="6604000" y="2603500"/>
-            <a:ext cx="2095500" cy="1206500"/>
-          </a:xfrm>
-          <a:prstGeom prst="roundRect">
-            <a:avLst>
-              <a:gd name="adj" fmla="val 8000"/>
-            </a:avLst>
-          </a:prstGeom>
-          <a:solidFill>
-            <a:srgbClr val="142C42"/>
-          </a:solidFill>
-          <a:ln w="10160">
-            <a:solidFill>
-              <a:srgbClr val="142C42"/>
-            </a:solidFill>
-          </a:ln>
-        </p:spPr>
-        <p:style>
-          <a:lnRef idx="1">
-            <a:schemeClr val="accent1"/>
-          </a:lnRef>
-          <a:fillRef idx="3">
-            <a:schemeClr val="accent1"/>
-          </a:fillRef>
-          <a:effectRef idx="2">
-            <a:schemeClr val="accent1"/>
-          </a:effectRef>
-          <a:fontRef idx="minor">
-            <a:schemeClr val="lt1"/>
-          </a:fontRef>
-        </p:style>
-        <p:txBody>
-          <a:bodyPr rtlCol="0" anchor="ctr"/>
-          <a:lstStyle/>
-          <a:p>
-            <a:pPr algn="ctr"/>
-          </a:p>
-        </p:txBody>
-      </p:sp>
-      <p:sp>
-        <p:nvSpPr>
-          <p:cNvPr id="50" name="TextBox 49"/>
-          <p:cNvSpPr txBox="1"/>
-          <p:nvPr/>
-        </p:nvSpPr>
-        <p:spPr>
-          <a:xfrm>
-            <a:off x="6743700" y="2679700"/>
-            <a:ext cx="1816100" cy="1054100"/>
-          </a:xfrm>
-          <a:prstGeom prst="rect">
-            <a:avLst/>
-          </a:prstGeom>
-          <a:noFill/>
-        </p:spPr>
-        <p:txBody>
-          <a:bodyPr wrap="none" lIns="0" rIns="0" tIns="0" bIns="0" anchor="t">
-            <a:spAutoFit/>
-          </a:bodyPr>
-          <a:lstStyle/>
-          <a:p>
-            <a:pPr algn="ctr">
-              <a:lnSpc>
-                <a:spcPts val="2700"/>
-              </a:lnSpc>
-              <a:spcBef>
-                <a:spcPts val="0"/>
-              </a:spcBef>
-              <a:spcAft>
-                <a:spcPts val="0"/>
-              </a:spcAft>
-              <a:defRPr sz="2000" b="1">
-                <a:solidFill>
-                  <a:srgbClr val="FFFFFF"/>
-                </a:solidFill>
-                <a:latin typeface="Microsoft JhengHei"/>
-              </a:defRPr>
-            </a:pPr>
-            <a:r>
-              <a:t>ADO Server</a:t>
-            </a:r>
-          </a:p>
-          <a:p>
-            <a:pPr algn="ctr">
-              <a:lnSpc>
-                <a:spcPts val="2700"/>
-              </a:lnSpc>
-              <a:spcBef>
-                <a:spcPts val="0"/>
-              </a:spcBef>
-              <a:spcAft>
-                <a:spcPts val="0"/>
-              </a:spcAft>
-              <a:defRPr sz="2000" b="1">
-                <a:solidFill>
-                  <a:srgbClr val="FFFFFF"/>
-                </a:solidFill>
-                <a:latin typeface="Microsoft JhengHei"/>
-              </a:defRPr>
-            </a:pPr>
-            <a:r>
-              <a:t>排程／存版本</a:t>
-            </a:r>
-          </a:p>
-          <a:p>
-            <a:pPr algn="ctr">
-              <a:lnSpc>
-                <a:spcPts val="2700"/>
-              </a:lnSpc>
-              <a:spcBef>
-                <a:spcPts val="0"/>
-              </a:spcBef>
-              <a:spcAft>
-                <a:spcPts val="0"/>
-              </a:spcAft>
-              <a:defRPr sz="2000" b="1">
-                <a:solidFill>
-                  <a:srgbClr val="FFFFFF"/>
-                </a:solidFill>
-                <a:latin typeface="Microsoft JhengHei"/>
-              </a:defRPr>
-            </a:pPr>
-            <a:r>
-              <a:t>管理 Release</a:t>
-            </a:r>
-          </a:p>
-        </p:txBody>
-      </p:sp>
-      <p:sp>
-        <p:nvSpPr>
-          <p:cNvPr id="51" name="Rounded Rectangle 50" descr="③ 管理 Agent&#10;下載／驗證匯入"/>
-          <p:cNvSpPr/>
-          <p:nvPr/>
-        </p:nvSpPr>
-        <p:spPr>
-          <a:xfrm>
-            <a:off x="4127500" y="4635500"/>
-            <a:ext cx="2222500" cy="952500"/>
-          </a:xfrm>
-          <a:prstGeom prst="roundRect">
-            <a:avLst>
-              <a:gd name="adj" fmla="val 8000"/>
-            </a:avLst>
-          </a:prstGeom>
-          <a:solidFill>
-            <a:srgbClr val="142C42"/>
-          </a:solidFill>
-          <a:ln w="10160">
-            <a:solidFill>
-              <a:srgbClr val="142C42"/>
-            </a:solidFill>
-          </a:ln>
-        </p:spPr>
-        <p:style>
-          <a:lnRef idx="1">
-            <a:schemeClr val="accent1"/>
-          </a:lnRef>
-          <a:fillRef idx="3">
-            <a:schemeClr val="accent1"/>
-          </a:fillRef>
-          <a:effectRef idx="2">
-            <a:schemeClr val="accent1"/>
-          </a:effectRef>
-          <a:fontRef idx="minor">
-            <a:schemeClr val="lt1"/>
-          </a:fontRef>
-        </p:style>
-        <p:txBody>
-          <a:bodyPr rtlCol="0" anchor="ctr"/>
-          <a:lstStyle/>
-          <a:p>
-            <a:pPr algn="ctr"/>
-          </a:p>
-        </p:txBody>
-      </p:sp>
-      <p:sp>
-        <p:nvSpPr>
-          <p:cNvPr id="52" name="TextBox 51"/>
-          <p:cNvSpPr txBox="1"/>
-          <p:nvPr/>
-        </p:nvSpPr>
-        <p:spPr>
-          <a:xfrm>
-            <a:off x="4267200" y="4756150"/>
-            <a:ext cx="1943100" cy="711200"/>
-          </a:xfrm>
-          <a:prstGeom prst="rect">
-            <a:avLst/>
-          </a:prstGeom>
-          <a:noFill/>
-        </p:spPr>
-        <p:txBody>
-          <a:bodyPr wrap="none" lIns="0" rIns="0" tIns="0" bIns="0" anchor="t">
-            <a:spAutoFit/>
-          </a:bodyPr>
-          <a:lstStyle/>
-          <a:p>
-            <a:pPr algn="ctr">
-              <a:lnSpc>
-                <a:spcPts val="2700"/>
-              </a:lnSpc>
-              <a:spcBef>
-                <a:spcPts val="0"/>
-              </a:spcBef>
-              <a:spcAft>
-                <a:spcPts val="0"/>
-              </a:spcAft>
-              <a:defRPr sz="2000" b="1">
-                <a:solidFill>
-                  <a:srgbClr val="FFFFFF"/>
-                </a:solidFill>
-                <a:latin typeface="Microsoft JhengHei"/>
-              </a:defRPr>
-            </a:pPr>
-            <a:r>
-              <a:t>③ 管理 Agent</a:t>
-            </a:r>
-          </a:p>
-          <a:p>
-            <a:pPr algn="ctr">
-              <a:lnSpc>
-                <a:spcPts val="2700"/>
-              </a:lnSpc>
-              <a:spcBef>
-                <a:spcPts val="0"/>
-              </a:spcBef>
-              <a:spcAft>
-                <a:spcPts val="0"/>
-              </a:spcAft>
-              <a:defRPr sz="2000" b="1">
-                <a:solidFill>
-                  <a:srgbClr val="FFFFFF"/>
-                </a:solidFill>
-                <a:latin typeface="Microsoft JhengHei"/>
-              </a:defRPr>
-            </a:pPr>
-            <a:r>
-              <a:t>下載／驗證匯入</a:t>
-            </a:r>
-          </a:p>
-        </p:txBody>
-      </p:sp>
-      <p:sp>
-        <p:nvSpPr>
-          <p:cNvPr id="53" name="Rounded Rectangle 52" descr="④ 部署人員&#10;選版與放行"/>
-          <p:cNvSpPr/>
-          <p:nvPr/>
-        </p:nvSpPr>
-        <p:spPr>
-          <a:xfrm>
-            <a:off x="6604000" y="4635500"/>
-            <a:ext cx="2095500" cy="952500"/>
-          </a:xfrm>
-          <a:prstGeom prst="roundRect">
-            <a:avLst>
-              <a:gd name="adj" fmla="val 8000"/>
-            </a:avLst>
-          </a:prstGeom>
-          <a:solidFill>
-            <a:srgbClr val="FFF1DA"/>
-          </a:solidFill>
-          <a:ln w="10160">
-            <a:solidFill>
-              <a:srgbClr val="C57227"/>
-            </a:solidFill>
-          </a:ln>
-        </p:spPr>
-        <p:style>
-          <a:lnRef idx="1">
-            <a:schemeClr val="accent1"/>
-          </a:lnRef>
-          <a:fillRef idx="3">
-            <a:schemeClr val="accent1"/>
-          </a:fillRef>
-          <a:effectRef idx="2">
-            <a:schemeClr val="accent1"/>
-          </a:effectRef>
-          <a:fontRef idx="minor">
-            <a:schemeClr val="lt1"/>
-          </a:fontRef>
-        </p:style>
-        <p:txBody>
-          <a:bodyPr rtlCol="0" anchor="ctr"/>
-          <a:lstStyle/>
-          <a:p>
-            <a:pPr algn="ctr"/>
-          </a:p>
-        </p:txBody>
-      </p:sp>
-      <p:sp>
-        <p:nvSpPr>
-          <p:cNvPr id="54" name="TextBox 53"/>
-          <p:cNvSpPr txBox="1"/>
-          <p:nvPr/>
-        </p:nvSpPr>
-        <p:spPr>
-          <a:xfrm>
-            <a:off x="6743700" y="4756150"/>
-            <a:ext cx="1816100" cy="711200"/>
-          </a:xfrm>
-          <a:prstGeom prst="rect">
-            <a:avLst/>
-          </a:prstGeom>
-          <a:noFill/>
-        </p:spPr>
-        <p:txBody>
-          <a:bodyPr wrap="none" lIns="0" rIns="0" tIns="0" bIns="0" anchor="t">
-            <a:spAutoFit/>
-          </a:bodyPr>
-          <a:lstStyle/>
-          <a:p>
-            <a:pPr algn="ctr">
-              <a:lnSpc>
-                <a:spcPts val="2700"/>
-              </a:lnSpc>
-              <a:spcBef>
-                <a:spcPts val="0"/>
-              </a:spcBef>
-              <a:spcAft>
-                <a:spcPts val="0"/>
-              </a:spcAft>
-              <a:defRPr sz="2000" b="1">
-                <a:solidFill>
-                  <a:srgbClr val="754519"/>
-                </a:solidFill>
-                <a:latin typeface="Microsoft JhengHei"/>
-              </a:defRPr>
-            </a:pPr>
-            <a:r>
-              <a:t>④ 部署人員</a:t>
-            </a:r>
-          </a:p>
-          <a:p>
-            <a:pPr algn="ctr">
-              <a:lnSpc>
-                <a:spcPts val="2700"/>
-              </a:lnSpc>
-              <a:spcBef>
-                <a:spcPts val="0"/>
-              </a:spcBef>
-              <a:spcAft>
-                <a:spcPts val="0"/>
-              </a:spcAft>
-              <a:defRPr sz="2000" b="1">
-                <a:solidFill>
-                  <a:srgbClr val="754519"/>
-                </a:solidFill>
-                <a:latin typeface="Microsoft JhengHei"/>
-              </a:defRPr>
-            </a:pPr>
-            <a:r>
-              <a:t>選版與放行</a:t>
-            </a:r>
-          </a:p>
-        </p:txBody>
-      </p:sp>
-      <p:sp>
-        <p:nvSpPr>
-          <p:cNvPr id="55" name="Rounded Rectangle 54" descr="⑤ 部署 Agent&#10;取得授權工作&#10;下載指定版本"/>
-          <p:cNvSpPr/>
-          <p:nvPr/>
-        </p:nvSpPr>
-        <p:spPr>
-          <a:xfrm>
-            <a:off x="9461500" y="2603500"/>
-            <a:ext cx="2032000" cy="1206500"/>
-          </a:xfrm>
-          <a:prstGeom prst="roundRect">
-            <a:avLst>
-              <a:gd name="adj" fmla="val 8000"/>
-            </a:avLst>
-          </a:prstGeom>
-          <a:solidFill>
-            <a:srgbClr val="087F8C"/>
-          </a:solidFill>
-          <a:ln w="10160">
-            <a:solidFill>
-              <a:srgbClr val="087F8C"/>
-            </a:solidFill>
-          </a:ln>
-        </p:spPr>
-        <p:style>
-          <a:lnRef idx="1">
-            <a:schemeClr val="accent1"/>
-          </a:lnRef>
-          <a:fillRef idx="3">
-            <a:schemeClr val="accent1"/>
-          </a:fillRef>
-          <a:effectRef idx="2">
-            <a:schemeClr val="accent1"/>
-          </a:effectRef>
-          <a:fontRef idx="minor">
-            <a:schemeClr val="lt1"/>
-          </a:fontRef>
-        </p:style>
-        <p:txBody>
-          <a:bodyPr rtlCol="0" anchor="ctr"/>
-          <a:lstStyle/>
-          <a:p>
-            <a:pPr algn="ctr"/>
-          </a:p>
-        </p:txBody>
-      </p:sp>
-      <p:sp>
-        <p:nvSpPr>
-          <p:cNvPr id="56" name="TextBox 55"/>
-          <p:cNvSpPr txBox="1"/>
-          <p:nvPr/>
-        </p:nvSpPr>
-        <p:spPr>
-          <a:xfrm>
-            <a:off x="9601200" y="2679700"/>
-            <a:ext cx="1752600" cy="1054100"/>
-          </a:xfrm>
-          <a:prstGeom prst="rect">
-            <a:avLst/>
-          </a:prstGeom>
-          <a:noFill/>
-        </p:spPr>
-        <p:txBody>
-          <a:bodyPr wrap="none" lIns="0" rIns="0" tIns="0" bIns="0" anchor="t">
-            <a:spAutoFit/>
-          </a:bodyPr>
-          <a:lstStyle/>
-          <a:p>
-            <a:pPr algn="ctr">
-              <a:lnSpc>
-                <a:spcPts val="2700"/>
-              </a:lnSpc>
-              <a:spcBef>
-                <a:spcPts val="0"/>
-              </a:spcBef>
-              <a:spcAft>
-                <a:spcPts val="0"/>
-              </a:spcAft>
-              <a:defRPr sz="2000" b="1">
-                <a:solidFill>
-                  <a:srgbClr val="FFFFFF"/>
-                </a:solidFill>
-                <a:latin typeface="Microsoft JhengHei"/>
-              </a:defRPr>
-            </a:pPr>
-            <a:r>
-              <a:t>⑤ 部署 Agent</a:t>
-            </a:r>
-          </a:p>
-          <a:p>
-            <a:pPr algn="ctr">
-              <a:lnSpc>
-                <a:spcPts val="2700"/>
-              </a:lnSpc>
-              <a:spcBef>
-                <a:spcPts val="0"/>
-              </a:spcBef>
-              <a:spcAft>
-                <a:spcPts val="0"/>
-              </a:spcAft>
-              <a:defRPr sz="2000" b="1">
-                <a:solidFill>
-                  <a:srgbClr val="FFFFFF"/>
-                </a:solidFill>
-                <a:latin typeface="Microsoft JhengHei"/>
-              </a:defRPr>
-            </a:pPr>
-            <a:r>
-              <a:t>取得授權工作</a:t>
-            </a:r>
-          </a:p>
-          <a:p>
-            <a:pPr algn="ctr">
-              <a:lnSpc>
-                <a:spcPts val="2700"/>
-              </a:lnSpc>
-              <a:spcBef>
-                <a:spcPts val="0"/>
-              </a:spcBef>
-              <a:spcAft>
-                <a:spcPts val="0"/>
-              </a:spcAft>
-              <a:defRPr sz="2000" b="1">
-                <a:solidFill>
-                  <a:srgbClr val="FFFFFF"/>
-                </a:solidFill>
-                <a:latin typeface="Microsoft JhengHei"/>
-              </a:defRPr>
-            </a:pPr>
-            <a:r>
-              <a:t>下載指定版本</a:t>
-            </a:r>
-          </a:p>
-        </p:txBody>
-      </p:sp>
-      <p:sp>
-        <p:nvSpPr>
-          <p:cNvPr id="57" name="Rounded Rectangle 56" descr="Windows 應用&#10;切換／檢查"/>
-          <p:cNvSpPr/>
-          <p:nvPr/>
-        </p:nvSpPr>
-        <p:spPr>
-          <a:xfrm>
-            <a:off x="9461500" y="4635500"/>
-            <a:ext cx="2032000" cy="952500"/>
-          </a:xfrm>
-          <a:prstGeom prst="roundRect">
-            <a:avLst>
-              <a:gd name="adj" fmla="val 8000"/>
-            </a:avLst>
-          </a:prstGeom>
-          <a:solidFill>
-            <a:srgbClr val="087F8C"/>
-          </a:solidFill>
-          <a:ln w="10160">
-            <a:solidFill>
-              <a:srgbClr val="087F8C"/>
-            </a:solidFill>
-          </a:ln>
-        </p:spPr>
-        <p:style>
-          <a:lnRef idx="1">
-            <a:schemeClr val="accent1"/>
-          </a:lnRef>
-          <a:fillRef idx="3">
-            <a:schemeClr val="accent1"/>
-          </a:fillRef>
-          <a:effectRef idx="2">
-            <a:schemeClr val="accent1"/>
-          </a:effectRef>
-          <a:fontRef idx="minor">
-            <a:schemeClr val="lt1"/>
-          </a:fontRef>
-        </p:style>
-        <p:txBody>
-          <a:bodyPr rtlCol="0" anchor="ctr"/>
-          <a:lstStyle/>
-          <a:p>
-            <a:pPr algn="ctr"/>
-          </a:p>
-        </p:txBody>
-      </p:sp>
-      <p:sp>
-        <p:nvSpPr>
-          <p:cNvPr id="58" name="TextBox 57"/>
-          <p:cNvSpPr txBox="1"/>
-          <p:nvPr/>
-        </p:nvSpPr>
-        <p:spPr>
-          <a:xfrm>
-            <a:off x="9601200" y="4756150"/>
-            <a:ext cx="1752600" cy="711200"/>
-          </a:xfrm>
-          <a:prstGeom prst="rect">
-            <a:avLst/>
-          </a:prstGeom>
-          <a:noFill/>
-        </p:spPr>
-        <p:txBody>
-          <a:bodyPr wrap="none" lIns="0" rIns="0" tIns="0" bIns="0" anchor="t">
-            <a:spAutoFit/>
-          </a:bodyPr>
-          <a:lstStyle/>
-          <a:p>
-            <a:pPr algn="ctr">
-              <a:lnSpc>
-                <a:spcPts val="2700"/>
-              </a:lnSpc>
-              <a:spcBef>
-                <a:spcPts val="0"/>
-              </a:spcBef>
-              <a:spcAft>
-                <a:spcPts val="0"/>
-              </a:spcAft>
-              <a:defRPr sz="2000" b="1">
-                <a:solidFill>
-                  <a:srgbClr val="FFFFFF"/>
-                </a:solidFill>
-                <a:latin typeface="Microsoft JhengHei"/>
-              </a:defRPr>
-            </a:pPr>
-            <a:r>
-              <a:t>Windows 應用</a:t>
-            </a:r>
-          </a:p>
-          <a:p>
-            <a:pPr algn="ctr">
-              <a:lnSpc>
-                <a:spcPts val="2700"/>
-              </a:lnSpc>
-              <a:spcBef>
-                <a:spcPts val="0"/>
-              </a:spcBef>
-              <a:spcAft>
-                <a:spcPts val="0"/>
-              </a:spcAft>
-              <a:defRPr sz="2000" b="1">
-                <a:solidFill>
-                  <a:srgbClr val="FFFFFF"/>
-                </a:solidFill>
-                <a:latin typeface="Microsoft JhengHei"/>
-              </a:defRPr>
-            </a:pPr>
-            <a:r>
-              <a:t>切換／檢查</a:t>
-            </a:r>
-          </a:p>
-        </p:txBody>
-      </p:sp>
-      <p:sp>
-        <p:nvSpPr>
-          <p:cNvPr id="59" name="Rectangle 58"/>
-          <p:cNvSpPr/>
-          <p:nvPr/>
-        </p:nvSpPr>
-        <p:spPr>
-          <a:xfrm>
-            <a:off x="5461000" y="4178300"/>
-            <a:ext cx="1143000" cy="342900"/>
-          </a:xfrm>
-          <a:prstGeom prst="rect">
-            <a:avLst/>
-          </a:prstGeom>
-          <a:solidFill>
-            <a:srgbClr val="F3F6FA"/>
-          </a:solidFill>
-          <a:ln>
-            <a:noFill/>
-          </a:ln>
-        </p:spPr>
-        <p:style>
-          <a:lnRef idx="1">
-            <a:schemeClr val="accent1"/>
-          </a:lnRef>
-          <a:fillRef idx="3">
-            <a:schemeClr val="accent1"/>
-          </a:fillRef>
-          <a:effectRef idx="2">
-            <a:schemeClr val="accent1"/>
-          </a:effectRef>
-          <a:fontRef idx="minor">
-            <a:schemeClr val="lt1"/>
-          </a:fontRef>
-        </p:style>
-        <p:txBody>
-          <a:bodyPr rtlCol="0" anchor="ctr"/>
-          <a:lstStyle/>
-          <a:p>
-            <a:pPr algn="ctr"/>
-          </a:p>
-        </p:txBody>
-      </p:sp>
-      <p:sp>
-        <p:nvSpPr>
-          <p:cNvPr id="60" name="TextBox 59"/>
-          <p:cNvSpPr txBox="1"/>
-          <p:nvPr/>
-        </p:nvSpPr>
-        <p:spPr>
-          <a:xfrm>
-            <a:off x="5461000" y="4178300"/>
-            <a:ext cx="1143000" cy="334010"/>
-          </a:xfrm>
-          <a:prstGeom prst="rect">
-            <a:avLst/>
-          </a:prstGeom>
-          <a:noFill/>
-        </p:spPr>
-        <p:txBody>
-          <a:bodyPr wrap="none" lIns="0" rIns="0" tIns="0" bIns="0" anchor="t">
-            <a:spAutoFit/>
-          </a:bodyPr>
-          <a:lstStyle/>
-          <a:p>
-            <a:pPr algn="ctr">
-              <a:lnSpc>
-                <a:spcPts val="2430"/>
-              </a:lnSpc>
-              <a:spcBef>
-                <a:spcPts val="0"/>
-              </a:spcBef>
-              <a:spcAft>
-                <a:spcPts val="0"/>
-              </a:spcAft>
-              <a:defRPr sz="1800" b="1">
-                <a:solidFill>
-                  <a:srgbClr val="087F8C"/>
-                </a:solidFill>
-                <a:latin typeface="Microsoft JhengHei"/>
-              </a:defRPr>
-            </a:pPr>
-            <a:r>
-              <a:t>派工</a:t>
-            </a:r>
-          </a:p>
-        </p:txBody>
-      </p:sp>
-      <p:sp>
-        <p:nvSpPr>
-          <p:cNvPr id="61" name="Rectangle 60"/>
-          <p:cNvSpPr/>
-          <p:nvPr/>
-        </p:nvSpPr>
-        <p:spPr>
-          <a:xfrm>
-            <a:off x="4064000" y="3492500"/>
-            <a:ext cx="2222500" cy="342900"/>
-          </a:xfrm>
-          <a:prstGeom prst="rect">
-            <a:avLst/>
-          </a:prstGeom>
-          <a:solidFill>
-            <a:srgbClr val="F3F6FA"/>
-          </a:solidFill>
-          <a:ln>
-            <a:noFill/>
-          </a:ln>
-        </p:spPr>
-        <p:style>
-          <a:lnRef idx="1">
-            <a:schemeClr val="accent1"/>
-          </a:lnRef>
-          <a:fillRef idx="3">
-            <a:schemeClr val="accent1"/>
-          </a:fillRef>
-          <a:effectRef idx="2">
-            <a:schemeClr val="accent1"/>
-          </a:effectRef>
-          <a:fontRef idx="minor">
-            <a:schemeClr val="lt1"/>
-          </a:fontRef>
-        </p:style>
-        <p:txBody>
-          <a:bodyPr rtlCol="0" anchor="ctr"/>
-          <a:lstStyle/>
-          <a:p>
-            <a:pPr algn="ctr"/>
-          </a:p>
-        </p:txBody>
-      </p:sp>
-      <p:sp>
-        <p:nvSpPr>
-          <p:cNvPr id="62" name="TextBox 61"/>
-          <p:cNvSpPr txBox="1"/>
-          <p:nvPr/>
-        </p:nvSpPr>
-        <p:spPr>
-          <a:xfrm>
-            <a:off x="4064000" y="3492500"/>
-            <a:ext cx="2222500" cy="334010"/>
-          </a:xfrm>
-          <a:prstGeom prst="rect">
-            <a:avLst/>
-          </a:prstGeom>
-          <a:noFill/>
-        </p:spPr>
-        <p:txBody>
-          <a:bodyPr wrap="none" lIns="0" rIns="0" tIns="0" bIns="0" anchor="t">
-            <a:spAutoFit/>
-          </a:bodyPr>
-          <a:lstStyle/>
-          <a:p>
-            <a:pPr algn="ctr">
-              <a:lnSpc>
-                <a:spcPts val="2430"/>
-              </a:lnSpc>
-              <a:spcBef>
-                <a:spcPts val="0"/>
-              </a:spcBef>
-              <a:spcAft>
-                <a:spcPts val="0"/>
-              </a:spcAft>
-              <a:defRPr sz="1800" b="1">
-                <a:solidFill>
-                  <a:srgbClr val="087F8C"/>
-                </a:solidFill>
-                <a:latin typeface="Microsoft JhengHei"/>
-              </a:defRPr>
-            </a:pPr>
-            <a:r>
-              <a:t>回存固定版本</a:t>
-            </a:r>
-          </a:p>
-        </p:txBody>
-      </p:sp>
-      <p:sp>
-        <p:nvSpPr>
-          <p:cNvPr id="63" name="TextBox 62"/>
-          <p:cNvSpPr txBox="1"/>
-          <p:nvPr/>
-        </p:nvSpPr>
-        <p:spPr>
-          <a:xfrm>
-            <a:off x="508000" y="5867400"/>
-            <a:ext cx="11176000" cy="368300"/>
-          </a:xfrm>
-          <a:prstGeom prst="rect">
-            <a:avLst/>
-          </a:prstGeom>
-          <a:noFill/>
-        </p:spPr>
-        <p:txBody>
-          <a:bodyPr wrap="none" lIns="0" rIns="0" tIns="0" bIns="0" anchor="t">
-            <a:spAutoFit/>
-          </a:bodyPr>
-          <a:lstStyle/>
-          <a:p>
-            <a:pPr algn="l">
-              <a:lnSpc>
-                <a:spcPts val="2700"/>
-              </a:lnSpc>
-              <a:spcBef>
-                <a:spcPts val="0"/>
-              </a:spcBef>
-              <a:spcAft>
-                <a:spcPts val="0"/>
-              </a:spcAft>
-              <a:defRPr sz="2000" b="0">
-                <a:solidFill>
-                  <a:srgbClr val="23384D"/>
-                </a:solidFill>
-                <a:latin typeface="Microsoft JhengHei"/>
-              </a:defRPr>
-            </a:pPr>
-            <a:r>
-              <a:t>接收器與匯入邏輯需實作；管理 Agent 不碰正式主機，每台目標另有部署 Agent。</a:t>
-            </a:r>
-          </a:p>
-        </p:txBody>
-      </p:sp>
-      <p:sp>
-        <p:nvSpPr>
-          <p:cNvPr id="64" name="Rectangle 63"/>
-          <p:cNvSpPr/>
-          <p:nvPr/>
-        </p:nvSpPr>
-        <p:spPr>
-          <a:xfrm>
-            <a:off x="508000" y="6413500"/>
-            <a:ext cx="11176000" cy="12700"/>
-          </a:xfrm>
-          <a:prstGeom prst="rect">
-            <a:avLst/>
-          </a:prstGeom>
-          <a:solidFill>
-            <a:srgbClr val="DCE5EE"/>
-          </a:solidFill>
-          <a:ln>
-            <a:noFill/>
-          </a:ln>
-        </p:spPr>
-        <p:style>
-          <a:lnRef idx="1">
-            <a:schemeClr val="accent1"/>
-          </a:lnRef>
-          <a:fillRef idx="3">
-            <a:schemeClr val="accent1"/>
-          </a:fillRef>
-          <a:effectRef idx="2">
-            <a:schemeClr val="accent1"/>
-          </a:effectRef>
-          <a:fontRef idx="minor">
-            <a:schemeClr val="lt1"/>
-          </a:fontRef>
-        </p:style>
-        <p:txBody>
-          <a:bodyPr rtlCol="0" anchor="ctr"/>
-          <a:lstStyle/>
-          <a:p>
-            <a:pPr algn="ctr"/>
-          </a:p>
-        </p:txBody>
-      </p:sp>
-      <p:sp>
-        <p:nvSpPr>
-          <p:cNvPr id="65" name="TextBox 64"/>
-          <p:cNvSpPr txBox="1"/>
-          <p:nvPr/>
-        </p:nvSpPr>
-        <p:spPr>
-          <a:xfrm>
-            <a:off x="508000" y="6527800"/>
-            <a:ext cx="9652000" cy="196850"/>
-          </a:xfrm>
-          <a:prstGeom prst="rect">
-            <a:avLst/>
-          </a:prstGeom>
-          <a:noFill/>
-        </p:spPr>
-        <p:txBody>
-          <a:bodyPr wrap="none" lIns="0" rIns="0" tIns="0" bIns="0" anchor="t">
-            <a:spAutoFit/>
-          </a:bodyPr>
-          <a:lstStyle/>
-          <a:p>
-            <a:pPr algn="l">
-              <a:lnSpc>
-                <a:spcPts val="1350"/>
-              </a:lnSpc>
-              <a:spcBef>
-                <a:spcPts val="0"/>
-              </a:spcBef>
-              <a:spcAft>
-                <a:spcPts val="0"/>
-              </a:spcAft>
-              <a:defRPr sz="1000" b="0">
-                <a:solidFill>
-                  <a:srgbClr val="52677B"/>
-                </a:solidFill>
-                <a:latin typeface="Microsoft JhengHei"/>
-              </a:defRPr>
-            </a:pPr>
-            <a:r>
-              <a:t>v0.6  |  初步計劃 · 正式上線另需批准</a:t>
-            </a:r>
-          </a:p>
-        </p:txBody>
-      </p:sp>
-      <p:sp>
-        <p:nvSpPr>
-          <p:cNvPr id="66" name="TextBox 65"/>
-          <p:cNvSpPr txBox="1"/>
-          <p:nvPr/>
-        </p:nvSpPr>
-        <p:spPr>
-          <a:xfrm>
-            <a:off x="10909300" y="6527800"/>
-            <a:ext cx="774700" cy="196850"/>
-          </a:xfrm>
-          <a:prstGeom prst="rect">
-            <a:avLst/>
-          </a:prstGeom>
-          <a:noFill/>
-        </p:spPr>
-        <p:txBody>
-          <a:bodyPr wrap="none" lIns="0" rIns="0" tIns="0" bIns="0" anchor="t">
-            <a:spAutoFit/>
-          </a:bodyPr>
-          <a:lstStyle/>
-          <a:p>
-            <a:pPr algn="l">
-              <a:lnSpc>
-                <a:spcPts val="1350"/>
-              </a:lnSpc>
-              <a:spcBef>
-                <a:spcPts val="0"/>
-              </a:spcBef>
-              <a:spcAft>
-                <a:spcPts val="0"/>
-              </a:spcAft>
-              <a:defRPr sz="1000" b="0">
-                <a:solidFill>
-                  <a:srgbClr val="52677B"/>
-                </a:solidFill>
-                <a:latin typeface="Microsoft JhengHei"/>
-              </a:defRPr>
-            </a:pPr>
-            <a:r>
-              <a:t>04 / 07</a:t>
-            </a:r>
-          </a:p>
-        </p:txBody>
-      </p:sp>
+        </p:spPr>
+      </p:pic>
     </p:spTree>
   </p:cSld>
   <p:clrMapOvr>
@@ -11467,7 +8646,7 @@
               </a:defRPr>
             </a:pPr>
             <a:r>
-              <a:t>v0.6  |  初步計劃 · 正式上線另需批准</a:t>
+              <a:t>v0.7  |  初步計劃 · 正式上線另需批准</a:t>
             </a:r>
           </a:p>
         </p:txBody>
@@ -12990,7 +10169,7 @@
               </a:defRPr>
             </a:pPr>
             <a:r>
-              <a:t>v0.6  |  初步計劃 · 正式上線另需批准</a:t>
+              <a:t>v0.7  |  初步計劃 · 正式上線另需批准</a:t>
             </a:r>
           </a:p>
         </p:txBody>
@@ -14269,7 +11448,7 @@
               </a:defRPr>
             </a:pPr>
             <a:r>
-              <a:t>v0.6  |  初步計劃 · 正式上線另需批准</a:t>
+              <a:t>v0.7  |  初步計劃 · 正式上線另需批准</a:t>
             </a:r>
           </a:p>
         </p:txBody>

</xml_diff>

<commit_message>
docs: simplify ADO management flow for cross-team presentation
</commit_message>
<xml_diff>
--- a/docs/presentations/windows-cd-initial-plan.pptx
+++ b/docs/presentations/windows-cd-initial-plan.pptx
@@ -716,6 +716,11 @@
         <p:txBody>
           <a:bodyPr/>
           <a:lstStyle/>
+          <a:p>
+            <a:r>
+              <a:t>本頁管理區改以三段關係說明：「成功通知 → 取得並保存版本 → 人員選版／選目標、確認放行」。這是簡化的業務流程視圖，不是取消中間串接元件；ADO 管理側包含受保護接收器及管理 Build Agent，不能將平台標題誤讀成全部由 ADO Server 本機執行或已有原生 GitLab 直連。技術細節保留於以下備註及研究文件，不要求所有聽眾理解 API、Importer 或 hash。</a:t>
+            </a:r>
+          </a:p>
           <a:p>
             <a:r>
               <a:t>本頁 v0.7 改為完整架構圖圖片，PPTX 中是高解析圖片，可編輯節點、容器與連線的原檔為 docs/presentations/diagrams/windows-deployment-map.drawio；獨立 PDF 可放大閱讀。圖內主架構與單台換版流程是兩個明確分隔的視圖，不是假裝一張純網路拓樸。圖面研究見 docs/research/end-to-end-architecture-diagram-design.md。</a:t>
@@ -7257,7 +7262,7 @@
       </p:sp>
       <p:pic>
         <p:nvPicPr>
-          <p:cNvPr id="4" name="Picture 3" descr="Windows 正式部署端到端架構：開發人員提交 GitLab，Runner 建置測試，成功事件通知受控接收器，ADO 管理 Agent 匯入固定產物，授權部署人員放行，由多台 Windows Target 的 Agent 換版；下方展開退出 F5、停服務、備份、換版、重啟、健康檢查與退版分支。"/>
+          <p:cNvPr id="4" name="Picture 3" descr="Windows 正式部署端到端架構：開發人員提交 GitLab，Runner 建置測試；成功後透過串接通知 ADO，管理側下載並保存可選版本，部署人員選版、選目標並放行，由多台 Windows Target 的 Agent 執行；下方展開 F5 換版與復原流程。"/>
           <p:cNvPicPr>
             <a:picLocks noChangeAspect="1"/>
           </p:cNvPicPr>

</xml_diff>

<commit_message>
docs: simplify release flow and verify deployment recovery feasibility
</commit_message>
<xml_diff>
--- a/docs/presentations/windows-cd-initial-plan.pptx
+++ b/docs/presentations/windows-cd-initial-plan.pptx
@@ -763,6 +763,11 @@
           </a:p>
           <a:p>
             <a:r>
+              <a:t>下半部更新為白話版並統一使用 ①～⑧ 圈號：① 取得已放行版本 → ② 下 F5 → ③ 停止服務 → ④ 備份舊版本 → ⑤ 安裝新版本 → ⑥ 重啟服務 → ⑦ 服務正常？ → ⑧ 上 F5。失敗路徑是還原舊版本、重啟與再檢查；成功恢復後仍記本次換版失敗。原本的鎖、前置閘門、有效備份、流量狀態核對與例外要求仍需實作，僅不放進主流程的長標籤。Agent／主機失聯不是同一個 Agent 能保證自動復原的情況，須另有監控及受控人工／獨立復原手段。</a:t>
+            </a:r>
+          </a:p>
+          <a:p>
+            <a:r>
               <a:t>下半部對每個核准目標重複：放行後下載／驗證、部署鎖與前置檢查 → 下 F5 並確認流量隔離條件 → 停止服務 → 備份目前版本 → 執行換版 → 重啟服務 → 檢查狀態。正常才上 F5，確認恢復成功後記錄新版本完成。</a:t>
             </a:r>
           </a:p>
@@ -784,6 +789,11 @@
           <a:p>
             <a:r>
               <a:t>完整串接依據：docs/research/gitlab-ado-event-trigger.md。</a:t>
+            </a:r>
+          </a:p>
+          <a:p>
+            <a:r>
+              <a:t>換版／復原可行性查核：docs/research/windows-release-recovery-feasibility.md。官方支援核准、指定 Build Artifact、Deployment Group 與 PowerShell／失敗條件，但不內建本案完整 rollback。POC 建議受保護 PowerShell 控制腳本換版失敗時嘗試復原，復原成功也保留原部署 failed；不要在 finally 無條件上 F5。Agent／主機失聯時需獨立監控及復原手段。限制同時部署比例不等於保證失敗停止所有後續主機；初期採單台 canary，下一台另設成功相依／人工放行，正式 fail-stop 需驗證或受控編排。匯入完成後，部署與退版不必再回 GitLab 取 latest。上述為文件查證，未完成實機 POC。</a:t>
             </a:r>
           </a:p>
           <a:p>

</xml_diff>

<commit_message>
docs: align release flow colors and clarify branch-specific deployment strategies
</commit_message>
<xml_diff>
--- a/docs/presentations/windows-cd-initial-plan.pptx
+++ b/docs/presentations/windows-cd-initial-plan.pptx
@@ -748,7 +748,7 @@
           </a:p>
           <a:p>
             <a:r>
-              <a:t>Production 關閉 artifact 自動 release trigger，授權人員選確切 importer build、應用與目標建立 Classic Release，stage 設 Manual only 與具名 pre-deployment approval；允許同一人發起與放行。任何版本／目標變更須重新放行。SIT/UAT 的三分支分流留下一頁說明。</a:t>
+              <a:t>Production 關閉 artifact 自動 release trigger，授權人員選確切 importer build、應用與目標建立 Classic Release，stage 設 Manual only 與具名 pre-deployment approval；允許同一人發起與放行。任何版本／目標變更須重新放行。分支與部署策略留下一頁說明。</a:t>
             </a:r>
           </a:p>
           <a:p>
@@ -893,7 +893,12 @@
           <a:lstStyle/>
           <a:p>
             <a:r>
-              <a:t>保留舊版第 5 頁的三分支映射。三個分支各自建置，不主張同一份內容由 UAT 晉升 Production。接收器與 importer 用 GitLab API 複核固定專案、精確 ref、pipeline source=push、非 tag、SHA、成功狀態與必要 jobs，再路由到三組固定 importer＋單環境 Classic Release。Webhook 與 queue 參數只是提示，不是可信任的環境判斷。</a:t>
+              <a:t>本頁改以「分支 → 對應 CI/CD pipeline → 換版策略」說明，不再限制為固定三分支。保留 master／SIT、pre-production／UAT 的目前規劃；正式分支可能包括 production、production-bq1、production-bq2、production-nh 等。這些是平行分支名稱，不是 Git 分支內的子分支，不推定名稱所代表的地點。正式分支合併一列不代表共用同一個 pipeline；不同分支可有不同建置、測試、產物、目標集合、逐台／分批、F5／服務操作及復原程序，實際映射待確認。各分支各自建置，不宣稱同一產物跨環境晉升。</a:t>
+            </a:r>
+          </a:p>
+          <a:p>
+            <a:r>
+              <a:t>圖為邏輯 CI/CD 流程，不宣稱 GitLab 原生編排 ADO，亦不要求每分支獨立 YAML。初版三組固定 importer／Release 是實作例，擴充分支須同步調整精確來源允許清單、受保護的目標與策略映射；不可自動信任任何 production 前綴。GitLab API 複核專案、精確 ref、pipeline source、SHA 及必要 jobs，不信任事件或參數自稱的環境。正式分支仍須指定人員選確切版本與目標放行。</a:t>
             </a:r>
           </a:p>
           <a:p>
@@ -5413,7 +5418,7 @@
               </a:defRPr>
             </a:pPr>
             <a:r>
-              <a:t>03｜三分支、三環境</a:t>
+              <a:t>03｜分支與部署策略</a:t>
             </a:r>
           </a:p>
         </p:txBody>
@@ -7481,7 +7486,7 @@
               </a:defRPr>
             </a:pPr>
             <a:r>
-              <a:t>三分支各自建置；正式環境多一道人工放行</a:t>
+              <a:t>不同分支，可以有不同的 CI/CD 與換版方式</a:t>
             </a:r>
           </a:p>
         </p:txBody>
@@ -7526,7 +7531,7 @@
               </a:defRPr>
             </a:pPr>
             <a:r>
-              <a:t>master → SIT；pre-production → UAT；production → Production</a:t>
+              <a:t>來源分支 → 對應 pipeline → 部署策略；以下為示意</a:t>
             </a:r>
           </a:p>
         </p:txBody>
@@ -7539,8 +7544,8 @@
         </p:nvCxnSpPr>
         <p:spPr>
           <a:xfrm>
-            <a:off x="2984500" y="3778250"/>
-            <a:ext cx="698500" cy="0"/>
+            <a:off x="4699000" y="2508250"/>
+            <a:ext cx="571500" cy="0"/>
           </a:xfrm>
           <a:prstGeom prst="line">
             <a:avLst/>
@@ -7574,9 +7579,9 @@
           <p:nvPr/>
         </p:nvCxnSpPr>
         <p:spPr>
-          <a:xfrm flipV="1">
-            <a:off x="6096000" y="3771900"/>
-            <a:ext cx="508000" cy="6350"/>
+          <a:xfrm>
+            <a:off x="8128000" y="2508250"/>
+            <a:ext cx="571500" cy="0"/>
           </a:xfrm>
           <a:prstGeom prst="line">
             <a:avLst/>
@@ -7585,6 +7590,7 @@
             <a:solidFill>
               <a:srgbClr val="087F8C"/>
             </a:solidFill>
+            <a:tailEnd type="triangle" w="sm" len="sm"/>
           </a:ln>
         </p:spPr>
         <p:style>
@@ -7609,9 +7615,9 @@
           <p:nvPr/>
         </p:nvCxnSpPr>
         <p:spPr>
-          <a:xfrm flipV="1">
-            <a:off x="6604000" y="2565400"/>
-            <a:ext cx="0" cy="1206500"/>
+          <a:xfrm>
+            <a:off x="4699000" y="3587750"/>
+            <a:ext cx="571500" cy="0"/>
           </a:xfrm>
           <a:prstGeom prst="line">
             <a:avLst/>
@@ -7620,6 +7626,7 @@
             <a:solidFill>
               <a:srgbClr val="087F8C"/>
             </a:solidFill>
+            <a:tailEnd type="triangle" w="sm" len="sm"/>
           </a:ln>
         </p:spPr>
         <p:style>
@@ -7645,8 +7652,8 @@
         </p:nvCxnSpPr>
         <p:spPr>
           <a:xfrm>
-            <a:off x="6604000" y="2565400"/>
-            <a:ext cx="952500" cy="6350"/>
+            <a:off x="8128000" y="3587750"/>
+            <a:ext cx="571500" cy="0"/>
           </a:xfrm>
           <a:prstGeom prst="line">
             <a:avLst/>
@@ -7681,8 +7688,8 @@
         </p:nvCxnSpPr>
         <p:spPr>
           <a:xfrm>
-            <a:off x="6096000" y="3778250"/>
-            <a:ext cx="1460500" cy="0"/>
+            <a:off x="4699000" y="4953000"/>
+            <a:ext cx="571500" cy="0"/>
           </a:xfrm>
           <a:prstGeom prst="line">
             <a:avLst/>
@@ -7716,9 +7723,9 @@
           <p:nvPr/>
         </p:nvCxnSpPr>
         <p:spPr>
-          <a:xfrm flipV="1">
-            <a:off x="6096000" y="3771900"/>
-            <a:ext cx="254000" cy="6350"/>
+          <a:xfrm>
+            <a:off x="8128000" y="4953000"/>
+            <a:ext cx="571500" cy="0"/>
           </a:xfrm>
           <a:prstGeom prst="line">
             <a:avLst/>
@@ -7727,6 +7734,7 @@
             <a:solidFill>
               <a:srgbClr val="087F8C"/>
             </a:solidFill>
+            <a:tailEnd type="triangle" w="sm" len="sm"/>
           </a:ln>
         </p:spPr>
         <p:style>
@@ -7744,123 +7752,16 @@
           </a:fontRef>
         </p:style>
       </p:cxnSp>
-      <p:cxnSp>
-        <p:nvCxnSpPr>
-          <p:cNvPr id="13" name="Connector 12"/>
-          <p:cNvCxnSpPr/>
-          <p:nvPr/>
-        </p:nvCxnSpPr>
-        <p:spPr>
-          <a:xfrm>
-            <a:off x="6350000" y="3771900"/>
-            <a:ext cx="0" cy="1244600"/>
-          </a:xfrm>
-          <a:prstGeom prst="line">
-            <a:avLst/>
-          </a:prstGeom>
-          <a:ln w="25400">
-            <a:solidFill>
-              <a:srgbClr val="087F8C"/>
-            </a:solidFill>
-          </a:ln>
-        </p:spPr>
-        <p:style>
-          <a:lnRef idx="2">
-            <a:schemeClr val="accent1"/>
-          </a:lnRef>
-          <a:fillRef idx="0">
-            <a:schemeClr val="accent1"/>
-          </a:fillRef>
-          <a:effectRef idx="1">
-            <a:schemeClr val="accent1"/>
-          </a:effectRef>
-          <a:fontRef idx="minor">
-            <a:schemeClr val="tx1"/>
-          </a:fontRef>
-        </p:style>
-      </p:cxnSp>
-      <p:cxnSp>
-        <p:nvCxnSpPr>
-          <p:cNvPr id="14" name="Connector 13"/>
-          <p:cNvCxnSpPr/>
-          <p:nvPr/>
-        </p:nvCxnSpPr>
-        <p:spPr>
-          <a:xfrm>
-            <a:off x="6350000" y="5016500"/>
-            <a:ext cx="571500" cy="0"/>
-          </a:xfrm>
-          <a:prstGeom prst="line">
-            <a:avLst/>
-          </a:prstGeom>
-          <a:ln w="25400">
-            <a:solidFill>
-              <a:srgbClr val="087F8C"/>
-            </a:solidFill>
-            <a:tailEnd type="triangle" w="sm" len="sm"/>
-          </a:ln>
-        </p:spPr>
-        <p:style>
-          <a:lnRef idx="2">
-            <a:schemeClr val="accent1"/>
-          </a:lnRef>
-          <a:fillRef idx="0">
-            <a:schemeClr val="accent1"/>
-          </a:fillRef>
-          <a:effectRef idx="1">
-            <a:schemeClr val="accent1"/>
-          </a:effectRef>
-          <a:fontRef idx="minor">
-            <a:schemeClr val="tx1"/>
-          </a:fontRef>
-        </p:style>
-      </p:cxnSp>
-      <p:cxnSp>
-        <p:nvCxnSpPr>
-          <p:cNvPr id="15" name="Connector 14"/>
-          <p:cNvCxnSpPr/>
-          <p:nvPr/>
-        </p:nvCxnSpPr>
-        <p:spPr>
-          <a:xfrm>
-            <a:off x="9652000" y="5016500"/>
-            <a:ext cx="508000" cy="0"/>
-          </a:xfrm>
-          <a:prstGeom prst="line">
-            <a:avLst/>
-          </a:prstGeom>
-          <a:ln w="25400">
-            <a:solidFill>
-              <a:srgbClr val="087F8C"/>
-            </a:solidFill>
-            <a:tailEnd type="triangle" w="sm" len="sm"/>
-          </a:ln>
-        </p:spPr>
-        <p:style>
-          <a:lnRef idx="2">
-            <a:schemeClr val="accent1"/>
-          </a:lnRef>
-          <a:fillRef idx="0">
-            <a:schemeClr val="accent1"/>
-          </a:fillRef>
-          <a:effectRef idx="1">
-            <a:schemeClr val="accent1"/>
-          </a:effectRef>
-          <a:fontRef idx="minor">
-            <a:schemeClr val="tx1"/>
-          </a:fontRef>
-        </p:style>
-      </p:cxnSp>
-      <p:sp>
-        <p:nvSpPr>
-          <p:cNvPr id="16" name="Rounded Rectangle 15" descr="GitLab CI&#10;建置固定版本"/>
+      <p:sp>
+        <p:nvSpPr>
+          <p:cNvPr id="13" name="Rounded Rectangle 12" descr="master"/>
           <p:cNvSpPr/>
           <p:nvPr/>
         </p:nvSpPr>
         <p:spPr>
           <a:xfrm>
-            <a:off x="508000" y="3238500"/>
-            <a:ext cx="2476500" cy="1079500"/>
+            <a:off x="508000" y="2095500"/>
+            <a:ext cx="4191000" cy="825500"/>
           </a:xfrm>
           <a:prstGeom prst="roundRect">
             <a:avLst>
@@ -7900,14 +7801,14 @@
       </p:sp>
       <p:sp>
         <p:nvSpPr>
-          <p:cNvPr id="17" name="TextBox 16"/>
+          <p:cNvPr id="14" name="TextBox 13"/>
           <p:cNvSpPr txBox="1"/>
           <p:nvPr/>
         </p:nvSpPr>
         <p:spPr>
           <a:xfrm>
-            <a:off x="647700" y="3422650"/>
-            <a:ext cx="2197100" cy="711200"/>
+            <a:off x="647700" y="2324100"/>
+            <a:ext cx="3911600" cy="368300"/>
           </a:xfrm>
           <a:prstGeom prst="rect">
             <a:avLst/>
@@ -7938,46 +7839,26 @@
               </a:defRPr>
             </a:pPr>
             <a:r>
-              <a:t>GitLab CI</a:t>
-            </a:r>
-          </a:p>
-          <a:p>
-            <a:pPr algn="ctr">
-              <a:lnSpc>
-                <a:spcPts val="2700"/>
-              </a:lnSpc>
-              <a:spcBef>
-                <a:spcPts val="0"/>
-              </a:spcBef>
-              <a:spcAft>
-                <a:spcPts val="0"/>
-              </a:spcAft>
-              <a:defRPr sz="2000" b="1">
-                <a:solidFill>
-                  <a:srgbClr val="FFFFFF"/>
-                </a:solidFill>
-                <a:latin typeface="Microsoft JhengHei"/>
-              </a:defRPr>
-            </a:pPr>
-            <a:r>
-              <a:t>建置固定版本</a:t>
-            </a:r>
-          </a:p>
-        </p:txBody>
-      </p:sp>
-      <p:sp>
-        <p:nvSpPr>
-          <p:cNvPr id="18" name="Diamond 17" descr="來源分支&#10;驗證與分流"/>
+              <a:t>master</a:t>
+            </a:r>
+          </a:p>
+        </p:txBody>
+      </p:sp>
+      <p:sp>
+        <p:nvSpPr>
+          <p:cNvPr id="15" name="Rounded Rectangle 14" descr="pre-production"/>
           <p:cNvSpPr/>
           <p:nvPr/>
         </p:nvSpPr>
         <p:spPr>
           <a:xfrm>
-            <a:off x="3683000" y="3175000"/>
-            <a:ext cx="2413000" cy="1206500"/>
-          </a:xfrm>
-          <a:prstGeom prst="diamond">
-            <a:avLst/>
+            <a:off x="508000" y="3175000"/>
+            <a:ext cx="4191000" cy="825500"/>
+          </a:xfrm>
+          <a:prstGeom prst="roundRect">
+            <a:avLst>
+              <a:gd name="adj" fmla="val 8000"/>
+            </a:avLst>
           </a:prstGeom>
           <a:solidFill>
             <a:srgbClr val="142C42"/>
@@ -8012,14 +7893,14 @@
       </p:sp>
       <p:sp>
         <p:nvSpPr>
-          <p:cNvPr id="19" name="TextBox 18"/>
+          <p:cNvPr id="16" name="TextBox 15"/>
           <p:cNvSpPr txBox="1"/>
           <p:nvPr/>
         </p:nvSpPr>
         <p:spPr>
           <a:xfrm>
-            <a:off x="4044950" y="3422650"/>
-            <a:ext cx="1689100" cy="711200"/>
+            <a:off x="647700" y="3403600"/>
+            <a:ext cx="3911600" cy="368300"/>
           </a:xfrm>
           <a:prstGeom prst="rect">
             <a:avLst/>
@@ -8050,9 +7931,215 @@
               </a:defRPr>
             </a:pPr>
             <a:r>
-              <a:t>來源分支</a:t>
-            </a:r>
-          </a:p>
+              <a:t>pre-production</a:t>
+            </a:r>
+          </a:p>
+        </p:txBody>
+      </p:sp>
+      <p:sp>
+        <p:nvSpPr>
+          <p:cNvPr id="17" name="Rounded Rectangle 16" descr="production / production-bq1&#10;production-bq2 / production-nh&#10;…（正式分支示例）"/>
+          <p:cNvSpPr/>
+          <p:nvPr/>
+        </p:nvSpPr>
+        <p:spPr>
+          <a:xfrm>
+            <a:off x="508000" y="4254500"/>
+            <a:ext cx="4191000" cy="1397000"/>
+          </a:xfrm>
+          <a:prstGeom prst="roundRect">
+            <a:avLst>
+              <a:gd name="adj" fmla="val 8000"/>
+            </a:avLst>
+          </a:prstGeom>
+          <a:solidFill>
+            <a:srgbClr val="142C42"/>
+          </a:solidFill>
+          <a:ln w="10160">
+            <a:solidFill>
+              <a:srgbClr val="142C42"/>
+            </a:solidFill>
+          </a:ln>
+        </p:spPr>
+        <p:style>
+          <a:lnRef idx="1">
+            <a:schemeClr val="accent1"/>
+          </a:lnRef>
+          <a:fillRef idx="3">
+            <a:schemeClr val="accent1"/>
+          </a:fillRef>
+          <a:effectRef idx="2">
+            <a:schemeClr val="accent1"/>
+          </a:effectRef>
+          <a:fontRef idx="minor">
+            <a:schemeClr val="lt1"/>
+          </a:fontRef>
+        </p:style>
+        <p:txBody>
+          <a:bodyPr rtlCol="0" anchor="ctr"/>
+          <a:lstStyle/>
+          <a:p>
+            <a:pPr algn="ctr"/>
+          </a:p>
+        </p:txBody>
+      </p:sp>
+      <p:sp>
+        <p:nvSpPr>
+          <p:cNvPr id="18" name="TextBox 17"/>
+          <p:cNvSpPr txBox="1"/>
+          <p:nvPr/>
+        </p:nvSpPr>
+        <p:spPr>
+          <a:xfrm>
+            <a:off x="647700" y="4438808"/>
+            <a:ext cx="3911600" cy="1028382"/>
+          </a:xfrm>
+          <a:prstGeom prst="rect">
+            <a:avLst/>
+          </a:prstGeom>
+          <a:noFill/>
+        </p:spPr>
+        <p:txBody>
+          <a:bodyPr wrap="none" lIns="0" rIns="0" tIns="0" bIns="0" anchor="t">
+            <a:spAutoFit/>
+          </a:bodyPr>
+          <a:lstStyle/>
+          <a:p>
+            <a:pPr algn="ctr">
+              <a:lnSpc>
+                <a:spcPts val="2632"/>
+              </a:lnSpc>
+              <a:spcBef>
+                <a:spcPts val="0"/>
+              </a:spcBef>
+              <a:spcAft>
+                <a:spcPts val="0"/>
+              </a:spcAft>
+              <a:defRPr sz="1950" b="1">
+                <a:solidFill>
+                  <a:srgbClr val="FFFFFF"/>
+                </a:solidFill>
+                <a:latin typeface="Microsoft JhengHei"/>
+              </a:defRPr>
+            </a:pPr>
+            <a:r>
+              <a:t>production / production-bq1</a:t>
+            </a:r>
+          </a:p>
+          <a:p>
+            <a:pPr algn="ctr">
+              <a:lnSpc>
+                <a:spcPts val="2632"/>
+              </a:lnSpc>
+              <a:spcBef>
+                <a:spcPts val="0"/>
+              </a:spcBef>
+              <a:spcAft>
+                <a:spcPts val="0"/>
+              </a:spcAft>
+              <a:defRPr sz="1950" b="1">
+                <a:solidFill>
+                  <a:srgbClr val="FFFFFF"/>
+                </a:solidFill>
+                <a:latin typeface="Microsoft JhengHei"/>
+              </a:defRPr>
+            </a:pPr>
+            <a:r>
+              <a:t>production-bq2 / production-nh</a:t>
+            </a:r>
+          </a:p>
+          <a:p>
+            <a:pPr algn="ctr">
+              <a:lnSpc>
+                <a:spcPts val="2632"/>
+              </a:lnSpc>
+              <a:spcBef>
+                <a:spcPts val="0"/>
+              </a:spcBef>
+              <a:spcAft>
+                <a:spcPts val="0"/>
+              </a:spcAft>
+              <a:defRPr sz="1950" b="1">
+                <a:solidFill>
+                  <a:srgbClr val="FFFFFF"/>
+                </a:solidFill>
+                <a:latin typeface="Microsoft JhengHei"/>
+              </a:defRPr>
+            </a:pPr>
+            <a:r>
+              <a:t>…（正式分支示例）</a:t>
+            </a:r>
+          </a:p>
+        </p:txBody>
+      </p:sp>
+      <p:sp>
+        <p:nvSpPr>
+          <p:cNvPr id="19" name="Rounded Rectangle 18" descr="SIT pipeline"/>
+          <p:cNvSpPr/>
+          <p:nvPr/>
+        </p:nvSpPr>
+        <p:spPr>
+          <a:xfrm>
+            <a:off x="5270500" y="2095500"/>
+            <a:ext cx="2857500" cy="825500"/>
+          </a:xfrm>
+          <a:prstGeom prst="roundRect">
+            <a:avLst>
+              <a:gd name="adj" fmla="val 8000"/>
+            </a:avLst>
+          </a:prstGeom>
+          <a:solidFill>
+            <a:srgbClr val="142C42"/>
+          </a:solidFill>
+          <a:ln w="10160">
+            <a:solidFill>
+              <a:srgbClr val="142C42"/>
+            </a:solidFill>
+          </a:ln>
+        </p:spPr>
+        <p:style>
+          <a:lnRef idx="1">
+            <a:schemeClr val="accent1"/>
+          </a:lnRef>
+          <a:fillRef idx="3">
+            <a:schemeClr val="accent1"/>
+          </a:fillRef>
+          <a:effectRef idx="2">
+            <a:schemeClr val="accent1"/>
+          </a:effectRef>
+          <a:fontRef idx="minor">
+            <a:schemeClr val="lt1"/>
+          </a:fontRef>
+        </p:style>
+        <p:txBody>
+          <a:bodyPr rtlCol="0" anchor="ctr"/>
+          <a:lstStyle/>
+          <a:p>
+            <a:pPr algn="ctr"/>
+          </a:p>
+        </p:txBody>
+      </p:sp>
+      <p:sp>
+        <p:nvSpPr>
+          <p:cNvPr id="20" name="TextBox 19"/>
+          <p:cNvSpPr txBox="1"/>
+          <p:nvPr/>
+        </p:nvSpPr>
+        <p:spPr>
+          <a:xfrm>
+            <a:off x="5410200" y="2324100"/>
+            <a:ext cx="2578100" cy="368300"/>
+          </a:xfrm>
+          <a:prstGeom prst="rect">
+            <a:avLst/>
+          </a:prstGeom>
+          <a:noFill/>
+        </p:spPr>
+        <p:txBody>
+          <a:bodyPr wrap="none" lIns="0" rIns="0" tIns="0" bIns="0" anchor="t">
+            <a:spAutoFit/>
+          </a:bodyPr>
+          <a:lstStyle/>
           <a:p>
             <a:pPr algn="ctr">
               <a:lnSpc>
@@ -8072,21 +8159,227 @@
               </a:defRPr>
             </a:pPr>
             <a:r>
-              <a:t>驗證與分流</a:t>
-            </a:r>
-          </a:p>
-        </p:txBody>
-      </p:sp>
-      <p:sp>
-        <p:nvSpPr>
-          <p:cNvPr id="20" name="Rounded Rectangle 19" descr="master → SIT&#10;匯入後自動換版"/>
+              <a:t>SIT pipeline</a:t>
+            </a:r>
+          </a:p>
+        </p:txBody>
+      </p:sp>
+      <p:sp>
+        <p:nvSpPr>
+          <p:cNvPr id="21" name="Rounded Rectangle 20" descr="UAT pipeline"/>
           <p:cNvSpPr/>
           <p:nvPr/>
         </p:nvSpPr>
         <p:spPr>
           <a:xfrm>
-            <a:off x="7556500" y="2095500"/>
-            <a:ext cx="4127500" cy="952500"/>
+            <a:off x="5270500" y="3175000"/>
+            <a:ext cx="2857500" cy="825500"/>
+          </a:xfrm>
+          <a:prstGeom prst="roundRect">
+            <a:avLst>
+              <a:gd name="adj" fmla="val 8000"/>
+            </a:avLst>
+          </a:prstGeom>
+          <a:solidFill>
+            <a:srgbClr val="142C42"/>
+          </a:solidFill>
+          <a:ln w="10160">
+            <a:solidFill>
+              <a:srgbClr val="142C42"/>
+            </a:solidFill>
+          </a:ln>
+        </p:spPr>
+        <p:style>
+          <a:lnRef idx="1">
+            <a:schemeClr val="accent1"/>
+          </a:lnRef>
+          <a:fillRef idx="3">
+            <a:schemeClr val="accent1"/>
+          </a:fillRef>
+          <a:effectRef idx="2">
+            <a:schemeClr val="accent1"/>
+          </a:effectRef>
+          <a:fontRef idx="minor">
+            <a:schemeClr val="lt1"/>
+          </a:fontRef>
+        </p:style>
+        <p:txBody>
+          <a:bodyPr rtlCol="0" anchor="ctr"/>
+          <a:lstStyle/>
+          <a:p>
+            <a:pPr algn="ctr"/>
+          </a:p>
+        </p:txBody>
+      </p:sp>
+      <p:sp>
+        <p:nvSpPr>
+          <p:cNvPr id="22" name="TextBox 21"/>
+          <p:cNvSpPr txBox="1"/>
+          <p:nvPr/>
+        </p:nvSpPr>
+        <p:spPr>
+          <a:xfrm>
+            <a:off x="5410200" y="3403600"/>
+            <a:ext cx="2578100" cy="368300"/>
+          </a:xfrm>
+          <a:prstGeom prst="rect">
+            <a:avLst/>
+          </a:prstGeom>
+          <a:noFill/>
+        </p:spPr>
+        <p:txBody>
+          <a:bodyPr wrap="none" lIns="0" rIns="0" tIns="0" bIns="0" anchor="t">
+            <a:spAutoFit/>
+          </a:bodyPr>
+          <a:lstStyle/>
+          <a:p>
+            <a:pPr algn="ctr">
+              <a:lnSpc>
+                <a:spcPts val="2700"/>
+              </a:lnSpc>
+              <a:spcBef>
+                <a:spcPts val="0"/>
+              </a:spcBef>
+              <a:spcAft>
+                <a:spcPts val="0"/>
+              </a:spcAft>
+              <a:defRPr sz="2000" b="1">
+                <a:solidFill>
+                  <a:srgbClr val="FFFFFF"/>
+                </a:solidFill>
+                <a:latin typeface="Microsoft JhengHei"/>
+              </a:defRPr>
+            </a:pPr>
+            <a:r>
+              <a:t>UAT pipeline</a:t>
+            </a:r>
+          </a:p>
+        </p:txBody>
+      </p:sp>
+      <p:sp>
+        <p:nvSpPr>
+          <p:cNvPr id="23" name="Rounded Rectangle 22" descr="各正式分支&#10;對應的 pipeline"/>
+          <p:cNvSpPr/>
+          <p:nvPr/>
+        </p:nvSpPr>
+        <p:spPr>
+          <a:xfrm>
+            <a:off x="5270500" y="4254500"/>
+            <a:ext cx="2857500" cy="1397000"/>
+          </a:xfrm>
+          <a:prstGeom prst="roundRect">
+            <a:avLst>
+              <a:gd name="adj" fmla="val 8000"/>
+            </a:avLst>
+          </a:prstGeom>
+          <a:solidFill>
+            <a:srgbClr val="142C42"/>
+          </a:solidFill>
+          <a:ln w="10160">
+            <a:solidFill>
+              <a:srgbClr val="142C42"/>
+            </a:solidFill>
+          </a:ln>
+        </p:spPr>
+        <p:style>
+          <a:lnRef idx="1">
+            <a:schemeClr val="accent1"/>
+          </a:lnRef>
+          <a:fillRef idx="3">
+            <a:schemeClr val="accent1"/>
+          </a:fillRef>
+          <a:effectRef idx="2">
+            <a:schemeClr val="accent1"/>
+          </a:effectRef>
+          <a:fontRef idx="minor">
+            <a:schemeClr val="lt1"/>
+          </a:fontRef>
+        </p:style>
+        <p:txBody>
+          <a:bodyPr rtlCol="0" anchor="ctr"/>
+          <a:lstStyle/>
+          <a:p>
+            <a:pPr algn="ctr"/>
+          </a:p>
+        </p:txBody>
+      </p:sp>
+      <p:sp>
+        <p:nvSpPr>
+          <p:cNvPr id="24" name="TextBox 23"/>
+          <p:cNvSpPr txBox="1"/>
+          <p:nvPr/>
+        </p:nvSpPr>
+        <p:spPr>
+          <a:xfrm>
+            <a:off x="5410200" y="4597400"/>
+            <a:ext cx="2578100" cy="711200"/>
+          </a:xfrm>
+          <a:prstGeom prst="rect">
+            <a:avLst/>
+          </a:prstGeom>
+          <a:noFill/>
+        </p:spPr>
+        <p:txBody>
+          <a:bodyPr wrap="none" lIns="0" rIns="0" tIns="0" bIns="0" anchor="t">
+            <a:spAutoFit/>
+          </a:bodyPr>
+          <a:lstStyle/>
+          <a:p>
+            <a:pPr algn="ctr">
+              <a:lnSpc>
+                <a:spcPts val="2700"/>
+              </a:lnSpc>
+              <a:spcBef>
+                <a:spcPts val="0"/>
+              </a:spcBef>
+              <a:spcAft>
+                <a:spcPts val="0"/>
+              </a:spcAft>
+              <a:defRPr sz="2000" b="1">
+                <a:solidFill>
+                  <a:srgbClr val="FFFFFF"/>
+                </a:solidFill>
+                <a:latin typeface="Microsoft JhengHei"/>
+              </a:defRPr>
+            </a:pPr>
+            <a:r>
+              <a:t>各正式分支</a:t>
+            </a:r>
+          </a:p>
+          <a:p>
+            <a:pPr algn="ctr">
+              <a:lnSpc>
+                <a:spcPts val="2700"/>
+              </a:lnSpc>
+              <a:spcBef>
+                <a:spcPts val="0"/>
+              </a:spcBef>
+              <a:spcAft>
+                <a:spcPts val="0"/>
+              </a:spcAft>
+              <a:defRPr sz="2000" b="1">
+                <a:solidFill>
+                  <a:srgbClr val="FFFFFF"/>
+                </a:solidFill>
+                <a:latin typeface="Microsoft JhengHei"/>
+              </a:defRPr>
+            </a:pPr>
+            <a:r>
+              <a:t>對應的 pipeline</a:t>
+            </a:r>
+          </a:p>
+        </p:txBody>
+      </p:sp>
+      <p:sp>
+        <p:nvSpPr>
+          <p:cNvPr id="25" name="Rounded Rectangle 24" descr="SIT｜可自動換版"/>
+          <p:cNvSpPr/>
+          <p:nvPr/>
+        </p:nvSpPr>
+        <p:spPr>
+          <a:xfrm>
+            <a:off x="8699500" y="2095500"/>
+            <a:ext cx="2984500" cy="825500"/>
           </a:xfrm>
           <a:prstGeom prst="roundRect">
             <a:avLst>
@@ -8126,14 +8419,14 @@
       </p:sp>
       <p:sp>
         <p:nvSpPr>
-          <p:cNvPr id="21" name="TextBox 20"/>
+          <p:cNvPr id="26" name="TextBox 25"/>
           <p:cNvSpPr txBox="1"/>
           <p:nvPr/>
         </p:nvSpPr>
         <p:spPr>
           <a:xfrm>
-            <a:off x="7696200" y="2216150"/>
-            <a:ext cx="3848100" cy="711200"/>
+            <a:off x="8839200" y="2324100"/>
+            <a:ext cx="2705100" cy="368300"/>
           </a:xfrm>
           <a:prstGeom prst="rect">
             <a:avLst/>
@@ -8164,43 +8457,21 @@
               </a:defRPr>
             </a:pPr>
             <a:r>
-              <a:t>master → SIT</a:t>
-            </a:r>
-          </a:p>
-          <a:p>
-            <a:pPr algn="ctr">
-              <a:lnSpc>
-                <a:spcPts val="2700"/>
-              </a:lnSpc>
-              <a:spcBef>
-                <a:spcPts val="0"/>
-              </a:spcBef>
-              <a:spcAft>
-                <a:spcPts val="0"/>
-              </a:spcAft>
-              <a:defRPr sz="2000" b="1">
-                <a:solidFill>
-                  <a:srgbClr val="FFFFFF"/>
-                </a:solidFill>
-                <a:latin typeface="Microsoft JhengHei"/>
-              </a:defRPr>
-            </a:pPr>
-            <a:r>
-              <a:t>匯入後自動換版</a:t>
-            </a:r>
-          </a:p>
-        </p:txBody>
-      </p:sp>
-      <p:sp>
-        <p:nvSpPr>
-          <p:cNvPr id="22" name="Rounded Rectangle 21" descr="pre-production → UAT&#10;匯入後自動換版"/>
+              <a:t>SIT｜可自動換版</a:t>
+            </a:r>
+          </a:p>
+        </p:txBody>
+      </p:sp>
+      <p:sp>
+        <p:nvSpPr>
+          <p:cNvPr id="27" name="Rounded Rectangle 26" descr="UAT｜可自動換版"/>
           <p:cNvSpPr/>
           <p:nvPr/>
         </p:nvSpPr>
         <p:spPr>
           <a:xfrm>
-            <a:off x="7556500" y="3302000"/>
-            <a:ext cx="4127500" cy="952500"/>
+            <a:off x="8699500" y="3175000"/>
+            <a:ext cx="2984500" cy="825500"/>
           </a:xfrm>
           <a:prstGeom prst="roundRect">
             <a:avLst>
@@ -8240,14 +8511,14 @@
       </p:sp>
       <p:sp>
         <p:nvSpPr>
-          <p:cNvPr id="23" name="TextBox 22"/>
+          <p:cNvPr id="28" name="TextBox 27"/>
           <p:cNvSpPr txBox="1"/>
           <p:nvPr/>
         </p:nvSpPr>
         <p:spPr>
           <a:xfrm>
-            <a:off x="7696200" y="3422650"/>
-            <a:ext cx="3848100" cy="711200"/>
+            <a:off x="8839200" y="3403600"/>
+            <a:ext cx="2705100" cy="368300"/>
           </a:xfrm>
           <a:prstGeom prst="rect">
             <a:avLst/>
@@ -8278,157 +8549,21 @@
               </a:defRPr>
             </a:pPr>
             <a:r>
-              <a:t>pre-production → UAT</a:t>
-            </a:r>
-          </a:p>
-          <a:p>
-            <a:pPr algn="ctr">
-              <a:lnSpc>
-                <a:spcPts val="2700"/>
-              </a:lnSpc>
-              <a:spcBef>
-                <a:spcPts val="0"/>
-              </a:spcBef>
-              <a:spcAft>
-                <a:spcPts val="0"/>
-              </a:spcAft>
-              <a:defRPr sz="2000" b="1">
-                <a:solidFill>
-                  <a:srgbClr val="FFFFFF"/>
-                </a:solidFill>
-                <a:latin typeface="Microsoft JhengHei"/>
-              </a:defRPr>
-            </a:pPr>
-            <a:r>
-              <a:t>匯入後自動換版</a:t>
-            </a:r>
-          </a:p>
-        </p:txBody>
-      </p:sp>
-      <p:sp>
-        <p:nvSpPr>
-          <p:cNvPr id="24" name="Rounded Rectangle 23" descr="production&#10;部署人員選版放行"/>
+              <a:t>UAT｜可自動換版</a:t>
+            </a:r>
+          </a:p>
+        </p:txBody>
+      </p:sp>
+      <p:sp>
+        <p:nvSpPr>
+          <p:cNvPr id="29" name="Rounded Rectangle 28" descr="正式｜授權後換版&#10;依目標採不同策略"/>
           <p:cNvSpPr/>
           <p:nvPr/>
         </p:nvSpPr>
         <p:spPr>
           <a:xfrm>
-            <a:off x="6921500" y="4508500"/>
-            <a:ext cx="2730500" cy="1016000"/>
-          </a:xfrm>
-          <a:prstGeom prst="roundRect">
-            <a:avLst>
-              <a:gd name="adj" fmla="val 8000"/>
-            </a:avLst>
-          </a:prstGeom>
-          <a:solidFill>
-            <a:srgbClr val="FFF1DA"/>
-          </a:solidFill>
-          <a:ln w="10160">
-            <a:solidFill>
-              <a:srgbClr val="C57227"/>
-            </a:solidFill>
-          </a:ln>
-        </p:spPr>
-        <p:style>
-          <a:lnRef idx="1">
-            <a:schemeClr val="accent1"/>
-          </a:lnRef>
-          <a:fillRef idx="3">
-            <a:schemeClr val="accent1"/>
-          </a:fillRef>
-          <a:effectRef idx="2">
-            <a:schemeClr val="accent1"/>
-          </a:effectRef>
-          <a:fontRef idx="minor">
-            <a:schemeClr val="lt1"/>
-          </a:fontRef>
-        </p:style>
-        <p:txBody>
-          <a:bodyPr rtlCol="0" anchor="ctr"/>
-          <a:lstStyle/>
-          <a:p>
-            <a:pPr algn="ctr"/>
-          </a:p>
-        </p:txBody>
-      </p:sp>
-      <p:sp>
-        <p:nvSpPr>
-          <p:cNvPr id="25" name="TextBox 24"/>
-          <p:cNvSpPr txBox="1"/>
-          <p:nvPr/>
-        </p:nvSpPr>
-        <p:spPr>
-          <a:xfrm>
-            <a:off x="7061200" y="4660900"/>
-            <a:ext cx="2451100" cy="711200"/>
-          </a:xfrm>
-          <a:prstGeom prst="rect">
-            <a:avLst/>
-          </a:prstGeom>
-          <a:noFill/>
-        </p:spPr>
-        <p:txBody>
-          <a:bodyPr wrap="none" lIns="0" rIns="0" tIns="0" bIns="0" anchor="t">
-            <a:spAutoFit/>
-          </a:bodyPr>
-          <a:lstStyle/>
-          <a:p>
-            <a:pPr algn="ctr">
-              <a:lnSpc>
-                <a:spcPts val="2700"/>
-              </a:lnSpc>
-              <a:spcBef>
-                <a:spcPts val="0"/>
-              </a:spcBef>
-              <a:spcAft>
-                <a:spcPts val="0"/>
-              </a:spcAft>
-              <a:defRPr sz="2000" b="1">
-                <a:solidFill>
-                  <a:srgbClr val="754519"/>
-                </a:solidFill>
-                <a:latin typeface="Microsoft JhengHei"/>
-              </a:defRPr>
-            </a:pPr>
-            <a:r>
-              <a:t>production</a:t>
-            </a:r>
-          </a:p>
-          <a:p>
-            <a:pPr algn="ctr">
-              <a:lnSpc>
-                <a:spcPts val="2700"/>
-              </a:lnSpc>
-              <a:spcBef>
-                <a:spcPts val="0"/>
-              </a:spcBef>
-              <a:spcAft>
-                <a:spcPts val="0"/>
-              </a:spcAft>
-              <a:defRPr sz="2000" b="1">
-                <a:solidFill>
-                  <a:srgbClr val="754519"/>
-                </a:solidFill>
-                <a:latin typeface="Microsoft JhengHei"/>
-              </a:defRPr>
-            </a:pPr>
-            <a:r>
-              <a:t>部署人員選版放行</a:t>
-            </a:r>
-          </a:p>
-        </p:txBody>
-      </p:sp>
-      <p:sp>
-        <p:nvSpPr>
-          <p:cNvPr id="26" name="Rounded Rectangle 25" descr="正式主機&#10;執行換版"/>
-          <p:cNvSpPr/>
-          <p:nvPr/>
-        </p:nvSpPr>
-        <p:spPr>
-          <a:xfrm>
-            <a:off x="10160000" y="4508500"/>
-            <a:ext cx="1524000" cy="1016000"/>
+            <a:off x="8699500" y="4254500"/>
+            <a:ext cx="2984500" cy="1397000"/>
           </a:xfrm>
           <a:prstGeom prst="roundRect">
             <a:avLst>
@@ -8468,14 +8603,14 @@
       </p:sp>
       <p:sp>
         <p:nvSpPr>
-          <p:cNvPr id="27" name="TextBox 26"/>
+          <p:cNvPr id="30" name="TextBox 29"/>
           <p:cNvSpPr txBox="1"/>
           <p:nvPr/>
         </p:nvSpPr>
         <p:spPr>
           <a:xfrm>
-            <a:off x="10299700" y="4660900"/>
-            <a:ext cx="1244600" cy="711200"/>
+            <a:off x="8839200" y="4597400"/>
+            <a:ext cx="2705100" cy="711200"/>
           </a:xfrm>
           <a:prstGeom prst="rect">
             <a:avLst/>
@@ -8506,7 +8641,7 @@
               </a:defRPr>
             </a:pPr>
             <a:r>
-              <a:t>正式主機</a:t>
+              <a:t>正式｜授權後換版</a:t>
             </a:r>
           </a:p>
           <a:p>
@@ -8528,14 +8663,14 @@
               </a:defRPr>
             </a:pPr>
             <a:r>
-              <a:t>執行換版</a:t>
-            </a:r>
-          </a:p>
-        </p:txBody>
-      </p:sp>
-      <p:sp>
-        <p:nvSpPr>
-          <p:cNvPr id="28" name="TextBox 27"/>
+              <a:t>依目標採不同策略</a:t>
+            </a:r>
+          </a:p>
+        </p:txBody>
+      </p:sp>
+      <p:sp>
+        <p:nvSpPr>
+          <p:cNvPr id="31" name="TextBox 30"/>
           <p:cNvSpPr txBox="1"/>
           <p:nvPr/>
         </p:nvSpPr>
@@ -8573,14 +8708,14 @@
               </a:defRPr>
             </a:pPr>
             <a:r>
-              <a:t>成功通知不是正式放行；正式放行綁定確切版本與目標。</a:t>
-            </a:r>
-          </a:p>
-        </p:txBody>
-      </p:sp>
-      <p:sp>
-        <p:nvSpPr>
-          <p:cNvPr id="29" name="Rectangle 28"/>
+              <a:t>分支可採不同建置、測試、目標與換版機制；正式部署仍須授權。</a:t>
+            </a:r>
+          </a:p>
+        </p:txBody>
+      </p:sp>
+      <p:sp>
+        <p:nvSpPr>
+          <p:cNvPr id="32" name="Rectangle 31"/>
           <p:cNvSpPr/>
           <p:nvPr/>
         </p:nvSpPr>
@@ -8623,7 +8758,7 @@
       </p:sp>
       <p:sp>
         <p:nvSpPr>
-          <p:cNvPr id="30" name="TextBox 29"/>
+          <p:cNvPr id="33" name="TextBox 32"/>
           <p:cNvSpPr txBox="1"/>
           <p:nvPr/>
         </p:nvSpPr>
@@ -8668,7 +8803,7 @@
       </p:sp>
       <p:sp>
         <p:nvSpPr>
-          <p:cNvPr id="31" name="TextBox 30"/>
+          <p:cNvPr id="34" name="TextBox 33"/>
           <p:cNvSpPr txBox="1"/>
           <p:nvPr/>
         </p:nvSpPr>

</xml_diff>

<commit_message>
docs: require manual functional verification before restoring F5 traffic
</commit_message>
<xml_diff>
--- a/docs/presentations/windows-cd-initial-plan.pptx
+++ b/docs/presentations/windows-cd-initial-plan.pptx
@@ -763,17 +763,27 @@
           </a:p>
           <a:p>
             <a:r>
+              <a:t>下半部新增強制人工關卡：⑦ 僅檢查服務／排程是否正常啟動；新版與復原舊版兩條路徑，都須由部署人員在隔離狀態驗證功能正常、確認放行後，才能執行⑧ 上 F5。人工節點沿用部署人員橘色，非 Agent 自動判定。新版功能驗證不通過走退版；舊版功能不通過保持隔離並通知。未確認、拒絕或逾時均不得恢復流量；逾時不視為自動同意，也不必然等同功能測試失敗。驗證須透過核准的隔離測試入口／直連方式，不為測試而預先恢復正式流量；實際入口與驗證項目待確認。</a:t>
+            </a:r>
+          </a:p>
+          <a:p>
+            <a:r>
+              <a:t>實作需把「部署／自動檢查」「人工功能驗證」「恢復流量」分成可強制等待與續行的控制步驟。初始 Release 的部署前核准不能代替此次中途關卡；需設計 Server Classic 支援的人工等待／分階段核准或受控外部編排，驗證成功續行、拒絕、逾時、Agent 失聯與回線對帳。人工決定綁定 release、target、版本及此次檢查結果，等待期間保留隔離與部署鎖；舊版復原也要有獨立確認，不可沿用新版確認。這是新增目標要求，尚未實作或實測。</a:t>
+            </a:r>
+          </a:p>
+          <a:p>
+            <a:r>
               <a:t>下半部更新為白話版並統一使用 ①～⑧ 圈號：① 取得已放行版本 → ② 下 F5 → ③ 停止服務 → ④ 備份舊版本 → ⑤ 安裝新版本 → ⑥ 重啟服務 → ⑦ 服務正常？ → ⑧ 上 F5。失敗路徑是還原舊版本、重啟與再檢查；成功恢復後仍記本次換版失敗。原本的鎖、前置閘門、有效備份、流量狀態核對與例外要求仍需實作，僅不放進主流程的長標籤。Agent／主機失聯不是同一個 Agent 能保證自動復原的情況，須另有監控及受控人工／獨立復原手段。</a:t>
             </a:r>
           </a:p>
           <a:p>
             <a:r>
-              <a:t>下半部對每個核准目標重複：放行後下載／驗證、部署鎖與前置檢查 → 下 F5 並確認流量隔離條件 → 停止服務 → 備份目前版本 → 執行換版 → 重啟服務 → 檢查狀態。正常才上 F5，確認恢復成功後記錄新版本完成。</a:t>
-            </a:r>
-          </a:p>
-          <a:p>
-            <a:r>
-              <a:t>換版、啟動或健康檢查失敗時，保持隔離，依受控腳本停止失敗版本、回復有效備份、重啟，再做復原健康檢查；正常才上 F5 並記錄「換版失敗、復原成功」，不能記為新版本部署成功。復原不健康或無可用備份時，保持隔離、停止後續換版、告警並交人員處理。</a:t>
+              <a:t>下半部對每個核准目標重複：放行後下載／驗證、部署鎖與前置檢查 → 下 F5 並確認流量隔離條件 → 停止服務 → 備份目前版本 → 執行換版 → 重啟服務 → 檢查狀態。正常且部署人員確認功能正常，才上 F5，確認恢復成功後記錄新版本完成。</a:t>
+            </a:r>
+          </a:p>
+          <a:p>
+            <a:r>
+              <a:t>換版、啟動或健康檢查失敗時，保持隔離，依受控腳本停止失敗版本、回復有效備份、重啟，再做復原健康檢查；正常且部署人員再次確認舊版功能正常，才上 F5 並記錄「換版失敗、復原成功」，不能記為新版本部署成功。復原不健康或無可用備份時，保持隔離、停止後續換版、告警並交人員處理。</a:t>
             </a:r>
           </a:p>
           <a:p>

</xml_diff>